<commit_message>
Finalize git part 1
</commit_message>
<xml_diff>
--- a/git_course/1_basics/git_basic.pptx
+++ b/git_course/1_basics/git_basic.pptx
@@ -40,11 +40,11 @@
     <p:sldId id="386" r:id="rId31"/>
     <p:sldId id="406" r:id="rId32"/>
     <p:sldId id="357" r:id="rId33"/>
-    <p:sldId id="359" r:id="rId34"/>
-    <p:sldId id="390" r:id="rId35"/>
-    <p:sldId id="429" r:id="rId36"/>
-    <p:sldId id="407" r:id="rId37"/>
-    <p:sldId id="372" r:id="rId38"/>
+    <p:sldId id="429" r:id="rId34"/>
+    <p:sldId id="359" r:id="rId35"/>
+    <p:sldId id="390" r:id="rId36"/>
+    <p:sldId id="372" r:id="rId37"/>
+    <p:sldId id="453" r:id="rId38"/>
     <p:sldId id="389" r:id="rId39"/>
     <p:sldId id="391" r:id="rId40"/>
     <p:sldId id="392" r:id="rId41"/>
@@ -53,8 +53,8 @@
     <p:sldId id="394" r:id="rId44"/>
     <p:sldId id="396" r:id="rId45"/>
     <p:sldId id="405" r:id="rId46"/>
-    <p:sldId id="397" r:id="rId47"/>
-    <p:sldId id="434" r:id="rId48"/>
+    <p:sldId id="454" r:id="rId47"/>
+    <p:sldId id="397" r:id="rId48"/>
     <p:sldId id="398" r:id="rId49"/>
     <p:sldId id="410" r:id="rId50"/>
     <p:sldId id="409" r:id="rId51"/>
@@ -263,7 +263,7 @@
           <a:p>
             <a:fld id="{3BADDCAA-88FC-44D4-A91A-DD0530AB88E0}" type="datetimeFigureOut">
               <a:rPr lang="en-NL" smtClean="0"/>
-              <a:t>31/08/2026</a:t>
+              <a:t>28/09/2026</a:t>
             </a:fld>
             <a:endParaRPr lang="en-NL"/>
           </a:p>
@@ -893,6 +893,22 @@
           <a:bodyPr/>
           <a:lstStyle/>
           <a:p>
+            <a:r>
+              <a:rPr lang="nl-NL" dirty="0"/>
+              <a:t>Demo: </a:t>
+            </a:r>
+            <a:r>
+              <a:rPr lang="nl-NL" dirty="0" err="1"/>
+              <a:t>Initial</a:t>
+            </a:r>
+            <a:r>
+              <a:rPr lang="nl-NL" dirty="0"/>
+              <a:t> </a:t>
+            </a:r>
+            <a:r>
+              <a:rPr lang="nl-NL" dirty="0" err="1"/>
+              <a:t>commits</a:t>
+            </a:r>
             <a:endParaRPr lang="nl-NL" dirty="0"/>
           </a:p>
         </p:txBody>
@@ -1898,16 +1914,13 @@
             </a:pPr>
             <a:r>
               <a:rPr lang="nl-NL" dirty="0"/>
-              <a:t>Demo: git </a:t>
+              <a:t>Demo: .</a:t>
             </a:r>
             <a:r>
               <a:rPr lang="nl-NL" dirty="0" err="1"/>
-              <a:t>ignore</a:t>
-            </a:r>
-            <a:r>
-              <a:rPr lang="nl-NL" dirty="0"/>
-              <a:t> met temp.txt</a:t>
-            </a:r>
+              <a:t>gitignore</a:t>
+            </a:r>
+            <a:endParaRPr lang="nl-NL" dirty="0"/>
           </a:p>
         </p:txBody>
       </p:sp>
@@ -2681,6 +2694,114 @@
         <p:cNvPr id="1" name="">
           <a:extLst>
             <a:ext uri="{FF2B5EF4-FFF2-40B4-BE49-F238E27FC236}">
+              <a16:creationId xmlns:a16="http://schemas.microsoft.com/office/drawing/2014/main" id="{BE4F412D-9B73-A479-8F97-16D85A40E507}"/>
+            </a:ext>
+          </a:extLst>
+        </p:cNvPr>
+        <p:cNvGrpSpPr/>
+        <p:nvPr/>
+      </p:nvGrpSpPr>
+      <p:grpSpPr>
+        <a:xfrm>
+          <a:off x="0" y="0"/>
+          <a:ext cx="0" cy="0"/>
+          <a:chOff x="0" y="0"/>
+          <a:chExt cx="0" cy="0"/>
+        </a:xfrm>
+      </p:grpSpPr>
+      <p:sp>
+        <p:nvSpPr>
+          <p:cNvPr id="2" name="Slide Image Placeholder 1">
+            <a:extLst>
+              <a:ext uri="{FF2B5EF4-FFF2-40B4-BE49-F238E27FC236}">
+                <a16:creationId xmlns:a16="http://schemas.microsoft.com/office/drawing/2014/main" id="{C34D35CC-38E3-F9A9-E27F-D03AFB408117}"/>
+              </a:ext>
+            </a:extLst>
+          </p:cNvPr>
+          <p:cNvSpPr>
+            <a:spLocks noGrp="1" noRot="1" noChangeAspect="1"/>
+          </p:cNvSpPr>
+          <p:nvPr>
+            <p:ph type="sldImg"/>
+          </p:nvPr>
+        </p:nvSpPr>
+        <p:spPr/>
+      </p:sp>
+      <p:sp>
+        <p:nvSpPr>
+          <p:cNvPr id="3" name="Notes Placeholder 2">
+            <a:extLst>
+              <a:ext uri="{FF2B5EF4-FFF2-40B4-BE49-F238E27FC236}">
+                <a16:creationId xmlns:a16="http://schemas.microsoft.com/office/drawing/2014/main" id="{689346DB-AE36-DAAF-43DF-8FCADA49BB06}"/>
+              </a:ext>
+            </a:extLst>
+          </p:cNvPr>
+          <p:cNvSpPr>
+            <a:spLocks noGrp="1"/>
+          </p:cNvSpPr>
+          <p:nvPr>
+            <p:ph type="body" idx="1"/>
+          </p:nvPr>
+        </p:nvSpPr>
+        <p:spPr/>
+        <p:txBody>
+          <a:bodyPr/>
+          <a:lstStyle/>
+          <a:p>
+            <a:endParaRPr lang="nl-NL" dirty="0"/>
+          </a:p>
+        </p:txBody>
+      </p:sp>
+      <p:sp>
+        <p:nvSpPr>
+          <p:cNvPr id="4" name="Slide Number Placeholder 3">
+            <a:extLst>
+              <a:ext uri="{FF2B5EF4-FFF2-40B4-BE49-F238E27FC236}">
+                <a16:creationId xmlns:a16="http://schemas.microsoft.com/office/drawing/2014/main" id="{18E5D9C7-35AE-30AD-4B24-4CF7A4DC8B43}"/>
+              </a:ext>
+            </a:extLst>
+          </p:cNvPr>
+          <p:cNvSpPr>
+            <a:spLocks noGrp="1"/>
+          </p:cNvSpPr>
+          <p:nvPr>
+            <p:ph type="sldNum" sz="quarter" idx="5"/>
+          </p:nvPr>
+        </p:nvSpPr>
+        <p:spPr/>
+        <p:txBody>
+          <a:bodyPr/>
+          <a:lstStyle/>
+          <a:p>
+            <a:fld id="{9583DEA5-E342-4DB2-B087-D0B9C490B19E}" type="slidenum">
+              <a:rPr lang="nl-NL" smtClean="0"/>
+              <a:t>33</a:t>
+            </a:fld>
+            <a:endParaRPr lang="nl-NL"/>
+          </a:p>
+        </p:txBody>
+      </p:sp>
+    </p:spTree>
+    <p:extLst>
+      <p:ext uri="{BB962C8B-B14F-4D97-AF65-F5344CB8AC3E}">
+        <p14:creationId xmlns:p14="http://schemas.microsoft.com/office/powerpoint/2010/main" val="3499154614"/>
+      </p:ext>
+    </p:extLst>
+  </p:cSld>
+  <p:clrMapOvr>
+    <a:masterClrMapping/>
+  </p:clrMapOvr>
+</p:notes>
+</file>
+
+<file path=ppt/notesSlides/notesSlide28.xml><?xml version="1.0" encoding="utf-8"?>
+<p:notes xmlns:a="http://schemas.openxmlformats.org/drawingml/2006/main" xmlns:r="http://schemas.openxmlformats.org/officeDocument/2006/relationships" xmlns:p="http://schemas.openxmlformats.org/presentationml/2006/main">
+  <p:cSld>
+    <p:spTree>
+      <p:nvGrpSpPr>
+        <p:cNvPr id="1" name="">
+          <a:extLst>
+            <a:ext uri="{FF2B5EF4-FFF2-40B4-BE49-F238E27FC236}">
               <a16:creationId xmlns:a16="http://schemas.microsoft.com/office/drawing/2014/main" id="{B29862C4-7B14-01F4-8EC1-95489C89F1AD}"/>
             </a:ext>
           </a:extLst>
@@ -2762,7 +2883,7 @@
           <a:p>
             <a:fld id="{9583DEA5-E342-4DB2-B087-D0B9C490B19E}" type="slidenum">
               <a:rPr lang="nl-NL" smtClean="0"/>
-              <a:t>33</a:t>
+              <a:t>34</a:t>
             </a:fld>
             <a:endParaRPr lang="nl-NL"/>
           </a:p>
@@ -2781,7 +2902,7 @@
 </p:notes>
 </file>
 
-<file path=ppt/notesSlides/notesSlide28.xml><?xml version="1.0" encoding="utf-8"?>
+<file path=ppt/notesSlides/notesSlide29.xml><?xml version="1.0" encoding="utf-8"?>
 <p:notes xmlns:a="http://schemas.openxmlformats.org/drawingml/2006/main" xmlns:r="http://schemas.openxmlformats.org/officeDocument/2006/relationships" xmlns:p="http://schemas.openxmlformats.org/presentationml/2006/main">
   <p:cSld>
     <p:spTree>
@@ -2870,7 +2991,7 @@
           <a:p>
             <a:fld id="{9583DEA5-E342-4DB2-B087-D0B9C490B19E}" type="slidenum">
               <a:rPr lang="nl-NL" smtClean="0"/>
-              <a:t>34</a:t>
+              <a:t>35</a:t>
             </a:fld>
             <a:endParaRPr lang="nl-NL"/>
           </a:p>
@@ -2880,114 +3001,6 @@
     <p:extLst>
       <p:ext uri="{BB962C8B-B14F-4D97-AF65-F5344CB8AC3E}">
         <p14:creationId xmlns:p14="http://schemas.microsoft.com/office/powerpoint/2010/main" val="2518536096"/>
-      </p:ext>
-    </p:extLst>
-  </p:cSld>
-  <p:clrMapOvr>
-    <a:masterClrMapping/>
-  </p:clrMapOvr>
-</p:notes>
-</file>
-
-<file path=ppt/notesSlides/notesSlide29.xml><?xml version="1.0" encoding="utf-8"?>
-<p:notes xmlns:a="http://schemas.openxmlformats.org/drawingml/2006/main" xmlns:r="http://schemas.openxmlformats.org/officeDocument/2006/relationships" xmlns:p="http://schemas.openxmlformats.org/presentationml/2006/main">
-  <p:cSld>
-    <p:spTree>
-      <p:nvGrpSpPr>
-        <p:cNvPr id="1" name="">
-          <a:extLst>
-            <a:ext uri="{FF2B5EF4-FFF2-40B4-BE49-F238E27FC236}">
-              <a16:creationId xmlns:a16="http://schemas.microsoft.com/office/drawing/2014/main" id="{BE4F412D-9B73-A479-8F97-16D85A40E507}"/>
-            </a:ext>
-          </a:extLst>
-        </p:cNvPr>
-        <p:cNvGrpSpPr/>
-        <p:nvPr/>
-      </p:nvGrpSpPr>
-      <p:grpSpPr>
-        <a:xfrm>
-          <a:off x="0" y="0"/>
-          <a:ext cx="0" cy="0"/>
-          <a:chOff x="0" y="0"/>
-          <a:chExt cx="0" cy="0"/>
-        </a:xfrm>
-      </p:grpSpPr>
-      <p:sp>
-        <p:nvSpPr>
-          <p:cNvPr id="2" name="Slide Image Placeholder 1">
-            <a:extLst>
-              <a:ext uri="{FF2B5EF4-FFF2-40B4-BE49-F238E27FC236}">
-                <a16:creationId xmlns:a16="http://schemas.microsoft.com/office/drawing/2014/main" id="{C34D35CC-38E3-F9A9-E27F-D03AFB408117}"/>
-              </a:ext>
-            </a:extLst>
-          </p:cNvPr>
-          <p:cNvSpPr>
-            <a:spLocks noGrp="1" noRot="1" noChangeAspect="1"/>
-          </p:cNvSpPr>
-          <p:nvPr>
-            <p:ph type="sldImg"/>
-          </p:nvPr>
-        </p:nvSpPr>
-        <p:spPr/>
-      </p:sp>
-      <p:sp>
-        <p:nvSpPr>
-          <p:cNvPr id="3" name="Notes Placeholder 2">
-            <a:extLst>
-              <a:ext uri="{FF2B5EF4-FFF2-40B4-BE49-F238E27FC236}">
-                <a16:creationId xmlns:a16="http://schemas.microsoft.com/office/drawing/2014/main" id="{689346DB-AE36-DAAF-43DF-8FCADA49BB06}"/>
-              </a:ext>
-            </a:extLst>
-          </p:cNvPr>
-          <p:cNvSpPr>
-            <a:spLocks noGrp="1"/>
-          </p:cNvSpPr>
-          <p:nvPr>
-            <p:ph type="body" idx="1"/>
-          </p:nvPr>
-        </p:nvSpPr>
-        <p:spPr/>
-        <p:txBody>
-          <a:bodyPr/>
-          <a:lstStyle/>
-          <a:p>
-            <a:endParaRPr lang="nl-NL" dirty="0"/>
-          </a:p>
-        </p:txBody>
-      </p:sp>
-      <p:sp>
-        <p:nvSpPr>
-          <p:cNvPr id="4" name="Slide Number Placeholder 3">
-            <a:extLst>
-              <a:ext uri="{FF2B5EF4-FFF2-40B4-BE49-F238E27FC236}">
-                <a16:creationId xmlns:a16="http://schemas.microsoft.com/office/drawing/2014/main" id="{18E5D9C7-35AE-30AD-4B24-4CF7A4DC8B43}"/>
-              </a:ext>
-            </a:extLst>
-          </p:cNvPr>
-          <p:cNvSpPr>
-            <a:spLocks noGrp="1"/>
-          </p:cNvSpPr>
-          <p:nvPr>
-            <p:ph type="sldNum" sz="quarter" idx="5"/>
-          </p:nvPr>
-        </p:nvSpPr>
-        <p:spPr/>
-        <p:txBody>
-          <a:bodyPr/>
-          <a:lstStyle/>
-          <a:p>
-            <a:fld id="{9583DEA5-E342-4DB2-B087-D0B9C490B19E}" type="slidenum">
-              <a:rPr lang="nl-NL" smtClean="0"/>
-              <a:t>35</a:t>
-            </a:fld>
-            <a:endParaRPr lang="nl-NL"/>
-          </a:p>
-        </p:txBody>
-      </p:sp>
-    </p:spTree>
-    <p:extLst>
-      <p:ext uri="{BB962C8B-B14F-4D97-AF65-F5344CB8AC3E}">
-        <p14:creationId xmlns:p14="http://schemas.microsoft.com/office/powerpoint/2010/main" val="3499154614"/>
       </p:ext>
     </p:extLst>
   </p:cSld>
@@ -3089,7 +3102,7 @@
         <p:cNvPr id="1" name="">
           <a:extLst>
             <a:ext uri="{FF2B5EF4-FFF2-40B4-BE49-F238E27FC236}">
-              <a16:creationId xmlns:a16="http://schemas.microsoft.com/office/drawing/2014/main" id="{C5BFF2BF-E153-194F-5A6C-805F7D1707F4}"/>
+              <a16:creationId xmlns:a16="http://schemas.microsoft.com/office/drawing/2014/main" id="{401CFB1A-342F-2F27-72E8-00445C999F94}"/>
             </a:ext>
           </a:extLst>
         </p:cNvPr>
@@ -3109,7 +3122,7 @@
           <p:cNvPr id="2" name="Slide Image Placeholder 1">
             <a:extLst>
               <a:ext uri="{FF2B5EF4-FFF2-40B4-BE49-F238E27FC236}">
-                <a16:creationId xmlns:a16="http://schemas.microsoft.com/office/drawing/2014/main" id="{EA846492-E91E-4E9D-201C-01689AB7F022}"/>
+                <a16:creationId xmlns:a16="http://schemas.microsoft.com/office/drawing/2014/main" id="{9CACBC0E-D327-D22F-821B-C714CA263C26}"/>
               </a:ext>
             </a:extLst>
           </p:cNvPr>
@@ -3127,7 +3140,7 @@
           <p:cNvPr id="3" name="Notes Placeholder 2">
             <a:extLst>
               <a:ext uri="{FF2B5EF4-FFF2-40B4-BE49-F238E27FC236}">
-                <a16:creationId xmlns:a16="http://schemas.microsoft.com/office/drawing/2014/main" id="{F1CC8F42-76FF-1565-2659-C6C0C4A022F3}"/>
+                <a16:creationId xmlns:a16="http://schemas.microsoft.com/office/drawing/2014/main" id="{B2EE9AE8-800A-6E87-0D32-7DAE9F71D149}"/>
               </a:ext>
             </a:extLst>
           </p:cNvPr>
@@ -3143,7 +3156,10 @@
           <a:bodyPr/>
           <a:lstStyle/>
           <a:p>
-            <a:endParaRPr lang="nl-NL" dirty="0"/>
+            <a:r>
+              <a:rPr lang="nl-NL" dirty="0"/>
+              <a:t>Demo: HEAD en refs</a:t>
+            </a:r>
           </a:p>
         </p:txBody>
       </p:sp>
@@ -3152,7 +3168,7 @@
           <p:cNvPr id="4" name="Slide Number Placeholder 3">
             <a:extLst>
               <a:ext uri="{FF2B5EF4-FFF2-40B4-BE49-F238E27FC236}">
-                <a16:creationId xmlns:a16="http://schemas.microsoft.com/office/drawing/2014/main" id="{792D0118-2E30-52F8-B6BC-2C1945BE93B7}"/>
+                <a16:creationId xmlns:a16="http://schemas.microsoft.com/office/drawing/2014/main" id="{ECAE885B-EB60-A902-A0FE-A588598F5990}"/>
               </a:ext>
             </a:extLst>
           </p:cNvPr>
@@ -3179,7 +3195,7 @@
     </p:spTree>
     <p:extLst>
       <p:ext uri="{BB962C8B-B14F-4D97-AF65-F5344CB8AC3E}">
-        <p14:creationId xmlns:p14="http://schemas.microsoft.com/office/powerpoint/2010/main" val="635941717"/>
+        <p14:creationId xmlns:p14="http://schemas.microsoft.com/office/powerpoint/2010/main" val="2332670534"/>
       </p:ext>
     </p:extLst>
   </p:cSld>
@@ -3197,7 +3213,7 @@
         <p:cNvPr id="1" name="">
           <a:extLst>
             <a:ext uri="{FF2B5EF4-FFF2-40B4-BE49-F238E27FC236}">
-              <a16:creationId xmlns:a16="http://schemas.microsoft.com/office/drawing/2014/main" id="{401CFB1A-342F-2F27-72E8-00445C999F94}"/>
+              <a16:creationId xmlns:a16="http://schemas.microsoft.com/office/drawing/2014/main" id="{5626DBA9-539A-B67B-26DF-3D08A0F6EDB2}"/>
             </a:ext>
           </a:extLst>
         </p:cNvPr>
@@ -3217,7 +3233,7 @@
           <p:cNvPr id="2" name="Slide Image Placeholder 1">
             <a:extLst>
               <a:ext uri="{FF2B5EF4-FFF2-40B4-BE49-F238E27FC236}">
-                <a16:creationId xmlns:a16="http://schemas.microsoft.com/office/drawing/2014/main" id="{9CACBC0E-D327-D22F-821B-C714CA263C26}"/>
+                <a16:creationId xmlns:a16="http://schemas.microsoft.com/office/drawing/2014/main" id="{9AB1B945-F139-BFF5-ACA2-2E0E5F69767C}"/>
               </a:ext>
             </a:extLst>
           </p:cNvPr>
@@ -3235,7 +3251,7 @@
           <p:cNvPr id="3" name="Notes Placeholder 2">
             <a:extLst>
               <a:ext uri="{FF2B5EF4-FFF2-40B4-BE49-F238E27FC236}">
-                <a16:creationId xmlns:a16="http://schemas.microsoft.com/office/drawing/2014/main" id="{B2EE9AE8-800A-6E87-0D32-7DAE9F71D149}"/>
+                <a16:creationId xmlns:a16="http://schemas.microsoft.com/office/drawing/2014/main" id="{D36F8B42-EB08-3CA9-59B4-55BBF4C7EDBD}"/>
               </a:ext>
             </a:extLst>
           </p:cNvPr>
@@ -3263,7 +3279,7 @@
           <p:cNvPr id="4" name="Slide Number Placeholder 3">
             <a:extLst>
               <a:ext uri="{FF2B5EF4-FFF2-40B4-BE49-F238E27FC236}">
-                <a16:creationId xmlns:a16="http://schemas.microsoft.com/office/drawing/2014/main" id="{ECAE885B-EB60-A902-A0FE-A588598F5990}"/>
+                <a16:creationId xmlns:a16="http://schemas.microsoft.com/office/drawing/2014/main" id="{66E80418-BA7F-9052-8C1A-C98979C9C1BF}"/>
               </a:ext>
             </a:extLst>
           </p:cNvPr>
@@ -3290,7 +3306,7 @@
     </p:spTree>
     <p:extLst>
       <p:ext uri="{BB962C8B-B14F-4D97-AF65-F5344CB8AC3E}">
-        <p14:creationId xmlns:p14="http://schemas.microsoft.com/office/powerpoint/2010/main" val="2332670534"/>
+        <p14:creationId xmlns:p14="http://schemas.microsoft.com/office/powerpoint/2010/main" val="1851207579"/>
       </p:ext>
     </p:extLst>
   </p:cSld>
@@ -4296,7 +4312,7 @@
         <p:cNvPr id="1" name="">
           <a:extLst>
             <a:ext uri="{FF2B5EF4-FFF2-40B4-BE49-F238E27FC236}">
-              <a16:creationId xmlns:a16="http://schemas.microsoft.com/office/drawing/2014/main" id="{3579D101-39E0-3A59-A7ED-084FD21DC6BA}"/>
+              <a16:creationId xmlns:a16="http://schemas.microsoft.com/office/drawing/2014/main" id="{F263B929-5902-A77A-1A34-7A5953D98FA8}"/>
             </a:ext>
           </a:extLst>
         </p:cNvPr>
@@ -4316,7 +4332,7 @@
           <p:cNvPr id="2" name="Slide Image Placeholder 1">
             <a:extLst>
               <a:ext uri="{FF2B5EF4-FFF2-40B4-BE49-F238E27FC236}">
-                <a16:creationId xmlns:a16="http://schemas.microsoft.com/office/drawing/2014/main" id="{F19319FA-E917-62D2-00D4-4E1D0957BA0A}"/>
+                <a16:creationId xmlns:a16="http://schemas.microsoft.com/office/drawing/2014/main" id="{C8DA9D05-8D0A-7A58-1692-83C13F7E3515}"/>
               </a:ext>
             </a:extLst>
           </p:cNvPr>
@@ -4334,7 +4350,7 @@
           <p:cNvPr id="3" name="Notes Placeholder 2">
             <a:extLst>
               <a:ext uri="{FF2B5EF4-FFF2-40B4-BE49-F238E27FC236}">
-                <a16:creationId xmlns:a16="http://schemas.microsoft.com/office/drawing/2014/main" id="{1B397D17-5A26-B46F-5661-95B29E1B96C3}"/>
+                <a16:creationId xmlns:a16="http://schemas.microsoft.com/office/drawing/2014/main" id="{2C31461C-089E-5CE3-5473-506EEBABCDDC}"/>
               </a:ext>
             </a:extLst>
           </p:cNvPr>
@@ -4359,7 +4375,7 @@
           <p:cNvPr id="4" name="Slide Number Placeholder 3">
             <a:extLst>
               <a:ext uri="{FF2B5EF4-FFF2-40B4-BE49-F238E27FC236}">
-                <a16:creationId xmlns:a16="http://schemas.microsoft.com/office/drawing/2014/main" id="{3107C67E-26FE-C27E-4229-5B7FEA6786B8}"/>
+                <a16:creationId xmlns:a16="http://schemas.microsoft.com/office/drawing/2014/main" id="{815F680D-BC96-AEC6-C2CA-3E9B7A6FD234}"/>
               </a:ext>
             </a:extLst>
           </p:cNvPr>
@@ -4377,7 +4393,7 @@
           <a:p>
             <a:fld id="{9583DEA5-E342-4DB2-B087-D0B9C490B19E}" type="slidenum">
               <a:rPr lang="nl-NL" smtClean="0"/>
-              <a:t>47</a:t>
+              <a:t>46</a:t>
             </a:fld>
             <a:endParaRPr lang="nl-NL"/>
           </a:p>
@@ -4386,7 +4402,7 @@
     </p:spTree>
     <p:extLst>
       <p:ext uri="{BB962C8B-B14F-4D97-AF65-F5344CB8AC3E}">
-        <p14:creationId xmlns:p14="http://schemas.microsoft.com/office/powerpoint/2010/main" val="4056120806"/>
+        <p14:creationId xmlns:p14="http://schemas.microsoft.com/office/powerpoint/2010/main" val="2797279954"/>
       </p:ext>
     </p:extLst>
   </p:cSld>
@@ -5376,18 +5392,7 @@
           <a:bodyPr/>
           <a:lstStyle/>
           <a:p>
-            <a:r>
-              <a:rPr lang="nl-NL" dirty="0"/>
-              <a:t>Demo: </a:t>
-            </a:r>
-            <a:r>
-              <a:rPr lang="nl-NL" dirty="0" err="1"/>
-              <a:t>merge</a:t>
-            </a:r>
-            <a:r>
-              <a:rPr lang="nl-NL" dirty="0"/>
-              <a:t> standard</a:t>
-            </a:r>
+            <a:endParaRPr lang="nl-NL" dirty="0"/>
           </a:p>
         </p:txBody>
       </p:sp>
@@ -5603,18 +5608,7 @@
           <a:bodyPr/>
           <a:lstStyle/>
           <a:p>
-            <a:r>
-              <a:rPr lang="nl-NL" dirty="0"/>
-              <a:t>Demo: </a:t>
-            </a:r>
-            <a:r>
-              <a:rPr lang="nl-NL" dirty="0" err="1"/>
-              <a:t>merge</a:t>
-            </a:r>
-            <a:r>
-              <a:rPr lang="nl-NL" dirty="0"/>
-              <a:t> standard</a:t>
-            </a:r>
+            <a:endParaRPr lang="nl-NL" dirty="0"/>
           </a:p>
         </p:txBody>
       </p:sp>
@@ -5722,18 +5716,7 @@
           <a:bodyPr/>
           <a:lstStyle/>
           <a:p>
-            <a:r>
-              <a:rPr lang="nl-NL" dirty="0"/>
-              <a:t>Demo: </a:t>
-            </a:r>
-            <a:r>
-              <a:rPr lang="nl-NL" dirty="0" err="1"/>
-              <a:t>merge</a:t>
-            </a:r>
-            <a:r>
-              <a:rPr lang="nl-NL" dirty="0"/>
-              <a:t> standard</a:t>
-            </a:r>
+            <a:endParaRPr lang="nl-NL" dirty="0"/>
           </a:p>
         </p:txBody>
       </p:sp>
@@ -6273,22 +6256,6 @@
           <a:bodyPr/>
           <a:lstStyle/>
           <a:p>
-            <a:r>
-              <a:rPr lang="nl-NL" dirty="0"/>
-              <a:t>Demo: </a:t>
-            </a:r>
-            <a:r>
-              <a:rPr lang="nl-NL" dirty="0" err="1"/>
-              <a:t>merge</a:t>
-            </a:r>
-            <a:r>
-              <a:rPr lang="nl-NL" dirty="0"/>
-              <a:t> </a:t>
-            </a:r>
-            <a:r>
-              <a:rPr lang="nl-NL" dirty="0" err="1"/>
-              <a:t>conflicts</a:t>
-            </a:r>
             <a:endParaRPr lang="nl-NL" dirty="0"/>
           </a:p>
         </p:txBody>
@@ -7061,7 +7028,18 @@
           <a:bodyPr/>
           <a:lstStyle/>
           <a:p>
-            <a:endParaRPr lang="nl-NL" dirty="0"/>
+            <a:r>
+              <a:rPr lang="nl-NL" dirty="0"/>
+              <a:t>Demo: </a:t>
+            </a:r>
+            <a:r>
+              <a:rPr lang="nl-NL" dirty="0" err="1"/>
+              <a:t>Create</a:t>
+            </a:r>
+            <a:r>
+              <a:rPr lang="nl-NL" dirty="0"/>
+              <a:t> repository</a:t>
+            </a:r>
           </a:p>
         </p:txBody>
       </p:sp>
@@ -7256,7 +7234,7 @@
           <a:p>
             <a:fld id="{0EBB069A-003F-4FC0-8534-236B0C5C7B5F}" type="datetimeFigureOut">
               <a:rPr lang="en-NL" smtClean="0"/>
-              <a:t>31/08/2026</a:t>
+              <a:t>28/09/2026</a:t>
             </a:fld>
             <a:endParaRPr lang="en-NL"/>
           </a:p>
@@ -7456,7 +7434,7 @@
           <a:p>
             <a:fld id="{0EBB069A-003F-4FC0-8534-236B0C5C7B5F}" type="datetimeFigureOut">
               <a:rPr lang="en-NL" smtClean="0"/>
-              <a:t>31/08/2026</a:t>
+              <a:t>28/09/2026</a:t>
             </a:fld>
             <a:endParaRPr lang="en-NL"/>
           </a:p>
@@ -7666,7 +7644,7 @@
           <a:p>
             <a:fld id="{0EBB069A-003F-4FC0-8534-236B0C5C7B5F}" type="datetimeFigureOut">
               <a:rPr lang="en-NL" smtClean="0"/>
-              <a:t>31/08/2026</a:t>
+              <a:t>28/09/2026</a:t>
             </a:fld>
             <a:endParaRPr lang="en-NL"/>
           </a:p>
@@ -7866,7 +7844,7 @@
           <a:p>
             <a:fld id="{0EBB069A-003F-4FC0-8534-236B0C5C7B5F}" type="datetimeFigureOut">
               <a:rPr lang="en-NL" smtClean="0"/>
-              <a:t>31/08/2026</a:t>
+              <a:t>28/09/2026</a:t>
             </a:fld>
             <a:endParaRPr lang="en-NL"/>
           </a:p>
@@ -8142,7 +8120,7 @@
           <a:p>
             <a:fld id="{0EBB069A-003F-4FC0-8534-236B0C5C7B5F}" type="datetimeFigureOut">
               <a:rPr lang="en-NL" smtClean="0"/>
-              <a:t>31/08/2026</a:t>
+              <a:t>28/09/2026</a:t>
             </a:fld>
             <a:endParaRPr lang="en-NL"/>
           </a:p>
@@ -8410,7 +8388,7 @@
           <a:p>
             <a:fld id="{0EBB069A-003F-4FC0-8534-236B0C5C7B5F}" type="datetimeFigureOut">
               <a:rPr lang="en-NL" smtClean="0"/>
-              <a:t>31/08/2026</a:t>
+              <a:t>28/09/2026</a:t>
             </a:fld>
             <a:endParaRPr lang="en-NL"/>
           </a:p>
@@ -8825,7 +8803,7 @@
           <a:p>
             <a:fld id="{0EBB069A-003F-4FC0-8534-236B0C5C7B5F}" type="datetimeFigureOut">
               <a:rPr lang="en-NL" smtClean="0"/>
-              <a:t>31/08/2026</a:t>
+              <a:t>28/09/2026</a:t>
             </a:fld>
             <a:endParaRPr lang="en-NL"/>
           </a:p>
@@ -8967,7 +8945,7 @@
           <a:p>
             <a:fld id="{0EBB069A-003F-4FC0-8534-236B0C5C7B5F}" type="datetimeFigureOut">
               <a:rPr lang="en-NL" smtClean="0"/>
-              <a:t>31/08/2026</a:t>
+              <a:t>28/09/2026</a:t>
             </a:fld>
             <a:endParaRPr lang="en-NL"/>
           </a:p>
@@ -9080,7 +9058,7 @@
           <a:p>
             <a:fld id="{0EBB069A-003F-4FC0-8534-236B0C5C7B5F}" type="datetimeFigureOut">
               <a:rPr lang="en-NL" smtClean="0"/>
-              <a:t>31/08/2026</a:t>
+              <a:t>28/09/2026</a:t>
             </a:fld>
             <a:endParaRPr lang="en-NL"/>
           </a:p>
@@ -9393,7 +9371,7 @@
           <a:p>
             <a:fld id="{0EBB069A-003F-4FC0-8534-236B0C5C7B5F}" type="datetimeFigureOut">
               <a:rPr lang="en-NL" smtClean="0"/>
-              <a:t>31/08/2026</a:t>
+              <a:t>28/09/2026</a:t>
             </a:fld>
             <a:endParaRPr lang="en-NL"/>
           </a:p>
@@ -9682,7 +9660,7 @@
           <a:p>
             <a:fld id="{0EBB069A-003F-4FC0-8534-236B0C5C7B5F}" type="datetimeFigureOut">
               <a:rPr lang="en-NL" smtClean="0"/>
-              <a:t>31/08/2026</a:t>
+              <a:t>28/09/2026</a:t>
             </a:fld>
             <a:endParaRPr lang="en-NL"/>
           </a:p>
@@ -9925,7 +9903,7 @@
           <a:p>
             <a:fld id="{0EBB069A-003F-4FC0-8534-236B0C5C7B5F}" type="datetimeFigureOut">
               <a:rPr lang="en-NL" smtClean="0"/>
-              <a:t>31/08/2026</a:t>
+              <a:t>28/09/2026</a:t>
             </a:fld>
             <a:endParaRPr lang="en-NL"/>
           </a:p>
@@ -10388,12 +10366,43 @@
         </p:nvSpPr>
         <p:spPr/>
         <p:txBody>
-          <a:bodyPr/>
+          <a:bodyPr>
+            <a:normAutofit fontScale="92500" lnSpcReduction="10000"/>
+          </a:bodyPr>
           <a:lstStyle/>
           <a:p>
             <a:r>
               <a:rPr lang="nl-NL" noProof="0" dirty="0"/>
-              <a:t>2024</a:t>
+              <a:t>2026</a:t>
+            </a:r>
+          </a:p>
+          <a:p>
+            <a:endParaRPr lang="nl-NL" dirty="0"/>
+          </a:p>
+          <a:p>
+            <a:endParaRPr lang="nl-NL" dirty="0"/>
+          </a:p>
+          <a:p>
+            <a:r>
+              <a:rPr lang="nl-NL" noProof="0" dirty="0">
+                <a:latin typeface="Courier New" panose="02070309020205020404" pitchFamily="49" charset="0"/>
+                <a:cs typeface="Courier New" panose="02070309020205020404" pitchFamily="49" charset="0"/>
+              </a:rPr>
+              <a:t>git </a:t>
+            </a:r>
+            <a:r>
+              <a:rPr lang="nl-NL" noProof="0" dirty="0" err="1">
+                <a:latin typeface="Courier New" panose="02070309020205020404" pitchFamily="49" charset="0"/>
+                <a:cs typeface="Courier New" panose="02070309020205020404" pitchFamily="49" charset="0"/>
+              </a:rPr>
+              <a:t>clone</a:t>
+            </a:r>
+            <a:r>
+              <a:rPr lang="nl-NL" dirty="0">
+                <a:latin typeface="Courier New" panose="02070309020205020404" pitchFamily="49" charset="0"/>
+                <a:cs typeface="Courier New" panose="02070309020205020404" pitchFamily="49" charset="0"/>
+              </a:rPr>
+              <a:t> https://github.com/LFKoning/git-cursus</a:t>
             </a:r>
           </a:p>
         </p:txBody>
@@ -10489,7 +10498,7 @@
             <a:pPr algn="ctr"/>
             <a:r>
               <a:rPr lang="en-US" b="1" dirty="0"/>
-              <a:t>staging area</a:t>
+              <a:t>staging area / index</a:t>
             </a:r>
           </a:p>
           <a:p>
@@ -13035,47 +13044,6 @@
                 <a:latin typeface="Courier New" panose="02070309020205020404" pitchFamily="49" charset="0"/>
                 <a:cs typeface="Courier New" panose="02070309020205020404" pitchFamily="49" charset="0"/>
               </a:rPr>
-              <a:t>│  │  </a:t>
-            </a:r>
-          </a:p>
-          <a:p>
-            <a:pPr marL="0" indent="0">
-              <a:spcBef>
-                <a:spcPts val="0"/>
-              </a:spcBef>
-              <a:buNone/>
-            </a:pPr>
-            <a:r>
-              <a:rPr lang="nl-NL" sz="1600" noProof="0" dirty="0">
-                <a:latin typeface="Courier New" panose="02070309020205020404" pitchFamily="49" charset="0"/>
-                <a:cs typeface="Courier New" panose="02070309020205020404" pitchFamily="49" charset="0"/>
-              </a:rPr>
-              <a:t>│  ├─ </a:t>
-            </a:r>
-            <a:r>
-              <a:rPr lang="nl-NL" sz="1600" noProof="0" dirty="0" err="1">
-                <a:latin typeface="Courier New" panose="02070309020205020404" pitchFamily="49" charset="0"/>
-                <a:cs typeface="Courier New" panose="02070309020205020404" pitchFamily="49" charset="0"/>
-              </a:rPr>
-              <a:t>remotes</a:t>
-            </a:r>
-            <a:endParaRPr lang="nl-NL" sz="1600" noProof="0" dirty="0">
-              <a:latin typeface="Courier New" panose="02070309020205020404" pitchFamily="49" charset="0"/>
-              <a:cs typeface="Courier New" panose="02070309020205020404" pitchFamily="49" charset="0"/>
-            </a:endParaRPr>
-          </a:p>
-          <a:p>
-            <a:pPr marL="0" indent="0">
-              <a:spcBef>
-                <a:spcPts val="0"/>
-              </a:spcBef>
-              <a:buNone/>
-            </a:pPr>
-            <a:r>
-              <a:rPr lang="nl-NL" sz="1600" noProof="0" dirty="0">
-                <a:latin typeface="Courier New" panose="02070309020205020404" pitchFamily="49" charset="0"/>
-                <a:cs typeface="Courier New" panose="02070309020205020404" pitchFamily="49" charset="0"/>
-              </a:rPr>
               <a:t>│  │</a:t>
             </a:r>
           </a:p>
@@ -13389,33 +13357,6 @@
               <a:rPr lang="nl-NL" sz="1600" noProof="0" dirty="0">
                 <a:cs typeface="Courier New" panose="02070309020205020404" pitchFamily="49" charset="0"/>
               </a:rPr>
-              <a:t>remote servers</a:t>
-            </a:r>
-          </a:p>
-          <a:p>
-            <a:pPr marL="0">
-              <a:spcBef>
-                <a:spcPts val="0"/>
-              </a:spcBef>
-              <a:buFontTx/>
-              <a:buChar char="-"/>
-            </a:pPr>
-            <a:endParaRPr lang="nl-NL" sz="1600" noProof="0" dirty="0">
-              <a:cs typeface="Courier New" panose="02070309020205020404" pitchFamily="49" charset="0"/>
-            </a:endParaRPr>
-          </a:p>
-          <a:p>
-            <a:pPr marL="0">
-              <a:spcBef>
-                <a:spcPts val="0"/>
-              </a:spcBef>
-              <a:buFontTx/>
-              <a:buChar char="-"/>
-            </a:pPr>
-            <a:r>
-              <a:rPr lang="nl-NL" sz="1600" noProof="0" dirty="0">
-                <a:cs typeface="Courier New" panose="02070309020205020404" pitchFamily="49" charset="0"/>
-              </a:rPr>
               <a:t>tags</a:t>
             </a:r>
           </a:p>
@@ -13489,7 +13430,7 @@
               <a:rPr lang="nl-NL" sz="1600" noProof="0" dirty="0">
                 <a:cs typeface="Courier New" panose="02070309020205020404" pitchFamily="49" charset="0"/>
               </a:rPr>
-              <a:t> / commit.</a:t>
+              <a:t> of commit.</a:t>
             </a:r>
           </a:p>
           <a:p>
@@ -13514,13 +13455,49 @@
               <a:rPr lang="nl-NL" sz="1600" dirty="0">
                 <a:cs typeface="Courier New" panose="02070309020205020404" pitchFamily="49" charset="0"/>
               </a:rPr>
-              <a:t>Metadata van</a:t>
+              <a:t>Metadata </a:t>
             </a:r>
             <a:r>
               <a:rPr lang="nl-NL" sz="1600" noProof="0" dirty="0">
                 <a:cs typeface="Courier New" panose="02070309020205020404" pitchFamily="49" charset="0"/>
               </a:rPr>
-              <a:t> alle bestanden; index / staging area / cache.</a:t>
+              <a:t>bestanden (staging area / cache).</a:t>
+            </a:r>
+          </a:p>
+        </p:txBody>
+      </p:sp>
+      <p:sp>
+        <p:nvSpPr>
+          <p:cNvPr id="4" name="TextBox 3">
+            <a:extLst>
+              <a:ext uri="{FF2B5EF4-FFF2-40B4-BE49-F238E27FC236}">
+                <a16:creationId xmlns:a16="http://schemas.microsoft.com/office/drawing/2014/main" id="{3A508C8C-FA3D-6D37-2C61-22A932DBE59C}"/>
+              </a:ext>
+            </a:extLst>
+          </p:cNvPr>
+          <p:cNvSpPr txBox="1"/>
+          <p:nvPr/>
+        </p:nvSpPr>
+        <p:spPr>
+          <a:xfrm>
+            <a:off x="9619967" y="6471982"/>
+            <a:ext cx="2499246" cy="307777"/>
+          </a:xfrm>
+          <a:prstGeom prst="rect">
+            <a:avLst/>
+          </a:prstGeom>
+          <a:noFill/>
+        </p:spPr>
+        <p:txBody>
+          <a:bodyPr wrap="square">
+            <a:spAutoFit/>
+          </a:bodyPr>
+          <a:lstStyle/>
+          <a:p>
+            <a:pPr algn="r"/>
+            <a:r>
+              <a:rPr lang="en-US" sz="1400" dirty="0"/>
+              <a:t>D: create repo.</a:t>
             </a:r>
           </a:p>
         </p:txBody>
@@ -15374,6 +15351,42 @@
           </a:p>
         </p:txBody>
       </p:sp>
+      <p:sp>
+        <p:nvSpPr>
+          <p:cNvPr id="7" name="TextBox 6">
+            <a:extLst>
+              <a:ext uri="{FF2B5EF4-FFF2-40B4-BE49-F238E27FC236}">
+                <a16:creationId xmlns:a16="http://schemas.microsoft.com/office/drawing/2014/main" id="{0A309791-BDF1-DBE4-B2B5-5425BE2AFD9F}"/>
+              </a:ext>
+            </a:extLst>
+          </p:cNvPr>
+          <p:cNvSpPr txBox="1"/>
+          <p:nvPr/>
+        </p:nvSpPr>
+        <p:spPr>
+          <a:xfrm>
+            <a:off x="9619967" y="6471982"/>
+            <a:ext cx="2499246" cy="307777"/>
+          </a:xfrm>
+          <a:prstGeom prst="rect">
+            <a:avLst/>
+          </a:prstGeom>
+          <a:noFill/>
+        </p:spPr>
+        <p:txBody>
+          <a:bodyPr wrap="square">
+            <a:spAutoFit/>
+          </a:bodyPr>
+          <a:lstStyle/>
+          <a:p>
+            <a:pPr algn="r"/>
+            <a:r>
+              <a:rPr lang="en-US" sz="1400" dirty="0"/>
+              <a:t>D: Initial commits.</a:t>
+            </a:r>
+          </a:p>
+        </p:txBody>
+      </p:sp>
     </p:spTree>
     <p:extLst>
       <p:ext uri="{BB962C8B-B14F-4D97-AF65-F5344CB8AC3E}">
@@ -15866,6 +15879,42 @@
           </a:fontRef>
         </p:style>
       </p:cxnSp>
+      <p:sp>
+        <p:nvSpPr>
+          <p:cNvPr id="4" name="TextBox 3">
+            <a:extLst>
+              <a:ext uri="{FF2B5EF4-FFF2-40B4-BE49-F238E27FC236}">
+                <a16:creationId xmlns:a16="http://schemas.microsoft.com/office/drawing/2014/main" id="{CBD9EA38-B6F5-F457-6553-8C6904B8F0ED}"/>
+              </a:ext>
+            </a:extLst>
+          </p:cNvPr>
+          <p:cNvSpPr txBox="1"/>
+          <p:nvPr/>
+        </p:nvSpPr>
+        <p:spPr>
+          <a:xfrm>
+            <a:off x="9619967" y="6471982"/>
+            <a:ext cx="2499246" cy="307777"/>
+          </a:xfrm>
+          <a:prstGeom prst="rect">
+            <a:avLst/>
+          </a:prstGeom>
+          <a:noFill/>
+        </p:spPr>
+        <p:txBody>
+          <a:bodyPr wrap="square">
+            <a:spAutoFit/>
+          </a:bodyPr>
+          <a:lstStyle/>
+          <a:p>
+            <a:pPr algn="r"/>
+            <a:r>
+              <a:rPr lang="en-US" sz="1400" dirty="0"/>
+              <a:t>D: commit objects.</a:t>
+            </a:r>
+          </a:p>
+        </p:txBody>
+      </p:sp>
     </p:spTree>
     <p:extLst>
       <p:ext uri="{BB962C8B-B14F-4D97-AF65-F5344CB8AC3E}">
@@ -16698,9 +16747,10 @@
               </a:spcAft>
             </a:pPr>
             <a:r>
-              <a:rPr lang="nl-NL" sz="2000" noProof="0" dirty="0"/>
-              <a:t>Onder de motorkap</a:t>
-            </a:r>
+              <a:rPr lang="nl-NL" sz="2000" dirty="0"/>
+              <a:t>In de praktijk</a:t>
+            </a:r>
+            <a:endParaRPr lang="nl-NL" sz="2000" noProof="0" dirty="0"/>
           </a:p>
           <a:p>
             <a:pPr>
@@ -16709,14 +16759,9 @@
               </a:spcAft>
             </a:pPr>
             <a:r>
-              <a:rPr lang="nl-NL" sz="2000" dirty="0"/>
-              <a:t>Wijzigingen </a:t>
-            </a:r>
-            <a:r>
-              <a:rPr lang="nl-NL" sz="2000" dirty="0" err="1"/>
-              <a:t>committen</a:t>
-            </a:r>
-            <a:endParaRPr lang="nl-NL" sz="2000" dirty="0"/>
+              <a:rPr lang="nl-NL" sz="2000" noProof="0" dirty="0"/>
+              <a:t>Onder de motorkap</a:t>
+            </a:r>
           </a:p>
           <a:p>
             <a:pPr>
@@ -16736,10 +16781,20 @@
               </a:spcAft>
             </a:pPr>
             <a:r>
-              <a:rPr lang="nl-NL" sz="2000"/>
+              <a:rPr lang="nl-NL" sz="2000" dirty="0"/>
               <a:t>Branches</a:t>
             </a:r>
-            <a:endParaRPr lang="nl-NL" sz="2000" dirty="0"/>
+          </a:p>
+          <a:p>
+            <a:pPr>
+              <a:spcAft>
+                <a:spcPts val="600"/>
+              </a:spcAft>
+            </a:pPr>
+            <a:r>
+              <a:rPr lang="nl-NL" sz="2000" dirty="0"/>
+              <a:t>Mergen</a:t>
+            </a:r>
           </a:p>
         </p:txBody>
       </p:sp>
@@ -19328,6 +19383,42 @@
           </a:fontRef>
         </p:style>
       </p:cxnSp>
+      <p:sp>
+        <p:nvSpPr>
+          <p:cNvPr id="14" name="TextBox 13">
+            <a:extLst>
+              <a:ext uri="{FF2B5EF4-FFF2-40B4-BE49-F238E27FC236}">
+                <a16:creationId xmlns:a16="http://schemas.microsoft.com/office/drawing/2014/main" id="{78C87E5C-59D7-4881-E7FD-6C34A6DC181D}"/>
+              </a:ext>
+            </a:extLst>
+          </p:cNvPr>
+          <p:cNvSpPr txBox="1"/>
+          <p:nvPr/>
+        </p:nvSpPr>
+        <p:spPr>
+          <a:xfrm>
+            <a:off x="9619967" y="6471982"/>
+            <a:ext cx="2499246" cy="307777"/>
+          </a:xfrm>
+          <a:prstGeom prst="rect">
+            <a:avLst/>
+          </a:prstGeom>
+          <a:noFill/>
+        </p:spPr>
+        <p:txBody>
+          <a:bodyPr wrap="square">
+            <a:spAutoFit/>
+          </a:bodyPr>
+          <a:lstStyle/>
+          <a:p>
+            <a:pPr algn="r"/>
+            <a:r>
+              <a:rPr lang="en-US" sz="1400" dirty="0"/>
+              <a:t>D: commit added file.</a:t>
+            </a:r>
+          </a:p>
+        </p:txBody>
+      </p:sp>
     </p:spTree>
     <p:extLst>
       <p:ext uri="{BB962C8B-B14F-4D97-AF65-F5344CB8AC3E}">
@@ -20392,6 +20483,47 @@
           </a:p>
         </p:txBody>
       </p:sp>
+      <p:sp>
+        <p:nvSpPr>
+          <p:cNvPr id="4" name="TextBox 3">
+            <a:extLst>
+              <a:ext uri="{FF2B5EF4-FFF2-40B4-BE49-F238E27FC236}">
+                <a16:creationId xmlns:a16="http://schemas.microsoft.com/office/drawing/2014/main" id="{B07BFF33-9256-6CDF-1D8F-1A2C536EBB64}"/>
+              </a:ext>
+            </a:extLst>
+          </p:cNvPr>
+          <p:cNvSpPr txBox="1"/>
+          <p:nvPr/>
+        </p:nvSpPr>
+        <p:spPr>
+          <a:xfrm>
+            <a:off x="9619967" y="6471982"/>
+            <a:ext cx="2499246" cy="307777"/>
+          </a:xfrm>
+          <a:prstGeom prst="rect">
+            <a:avLst/>
+          </a:prstGeom>
+          <a:noFill/>
+        </p:spPr>
+        <p:txBody>
+          <a:bodyPr wrap="square">
+            <a:spAutoFit/>
+          </a:bodyPr>
+          <a:lstStyle/>
+          <a:p>
+            <a:pPr algn="r"/>
+            <a:r>
+              <a:rPr lang="en-US" sz="1400" dirty="0"/>
+              <a:t>D: .</a:t>
+            </a:r>
+            <a:r>
+              <a:rPr lang="en-US" sz="1400" dirty="0" err="1"/>
+              <a:t>gitignore</a:t>
+            </a:r>
+            <a:endParaRPr lang="en-US" sz="1400" dirty="0"/>
+          </a:p>
+        </p:txBody>
+      </p:sp>
     </p:spTree>
     <p:extLst>
       <p:ext uri="{BB962C8B-B14F-4D97-AF65-F5344CB8AC3E}">
@@ -20605,13 +20737,13 @@
               <a:rPr lang="nl-NL" sz="1800" b="1" noProof="0" dirty="0">
                 <a:cs typeface="Courier New" panose="02070309020205020404" pitchFamily="49" charset="0"/>
               </a:rPr>
-              <a:t>geen enkel effect</a:t>
+              <a:t>geen effect</a:t>
             </a:r>
             <a:r>
               <a:rPr lang="nl-NL" sz="1800" noProof="0" dirty="0">
                 <a:cs typeface="Courier New" panose="02070309020205020404" pitchFamily="49" charset="0"/>
               </a:rPr>
-              <a:t> op bestanden die al in het </a:t>
+              <a:t> op bestanden in het </a:t>
             </a:r>
             <a:r>
               <a:rPr lang="nl-NL" sz="1800" noProof="0" dirty="0" err="1">
@@ -20623,27 +20755,30 @@
               <a:rPr lang="nl-NL" sz="1800" noProof="0" dirty="0">
                 <a:cs typeface="Courier New" panose="02070309020205020404" pitchFamily="49" charset="0"/>
               </a:rPr>
-              <a:t> staan! Soms moet je bestanden eerst verwijderen en dan aan </a:t>
-            </a:r>
+              <a:t>!</a:t>
+            </a:r>
+          </a:p>
+          <a:p>
+            <a:pPr marL="0" indent="0">
+              <a:buNone/>
+            </a:pPr>
             <a:r>
               <a:rPr lang="nl-NL" sz="1800" noProof="0" dirty="0">
-                <a:latin typeface="Courier New" panose="02070309020205020404" pitchFamily="49" charset="0"/>
-                <a:cs typeface="Courier New" panose="02070309020205020404" pitchFamily="49" charset="0"/>
-              </a:rPr>
-              <a:t>.</a:t>
+                <a:cs typeface="Courier New" panose="02070309020205020404" pitchFamily="49" charset="0"/>
+              </a:rPr>
+              <a:t>Ongewenste bestanden in een </a:t>
             </a:r>
             <a:r>
               <a:rPr lang="nl-NL" sz="1800" noProof="0" dirty="0" err="1">
-                <a:latin typeface="Courier New" panose="02070309020205020404" pitchFamily="49" charset="0"/>
-                <a:cs typeface="Courier New" panose="02070309020205020404" pitchFamily="49" charset="0"/>
-              </a:rPr>
-              <a:t>gitignore</a:t>
+                <a:cs typeface="Courier New" panose="02070309020205020404" pitchFamily="49" charset="0"/>
+              </a:rPr>
+              <a:t>repo</a:t>
             </a:r>
             <a:r>
               <a:rPr lang="nl-NL" sz="1800" noProof="0" dirty="0">
                 <a:cs typeface="Courier New" panose="02070309020205020404" pitchFamily="49" charset="0"/>
               </a:rPr>
-              <a:t> toevoegen.</a:t>
+              <a:t> moet je eerst verwijderen.</a:t>
             </a:r>
           </a:p>
           <a:p>
@@ -22172,6 +22307,42 @@
           </p:spPr>
         </p:pic>
       </p:grpSp>
+      <p:sp>
+        <p:nvSpPr>
+          <p:cNvPr id="4" name="TextBox 3">
+            <a:extLst>
+              <a:ext uri="{FF2B5EF4-FFF2-40B4-BE49-F238E27FC236}">
+                <a16:creationId xmlns:a16="http://schemas.microsoft.com/office/drawing/2014/main" id="{32EF98F6-AB85-5A37-A6D5-7A1C876B24A6}"/>
+              </a:ext>
+            </a:extLst>
+          </p:cNvPr>
+          <p:cNvSpPr txBox="1"/>
+          <p:nvPr/>
+        </p:nvSpPr>
+        <p:spPr>
+          <a:xfrm>
+            <a:off x="9619967" y="6471982"/>
+            <a:ext cx="2499246" cy="307777"/>
+          </a:xfrm>
+          <a:prstGeom prst="rect">
+            <a:avLst/>
+          </a:prstGeom>
+          <a:noFill/>
+        </p:spPr>
+        <p:txBody>
+          <a:bodyPr wrap="square">
+            <a:spAutoFit/>
+          </a:bodyPr>
+          <a:lstStyle/>
+          <a:p>
+            <a:pPr algn="r"/>
+            <a:r>
+              <a:rPr lang="en-US" sz="1400" dirty="0"/>
+              <a:t>D: git diff.</a:t>
+            </a:r>
+          </a:p>
+        </p:txBody>
+      </p:sp>
     </p:spTree>
     <p:extLst>
       <p:ext uri="{BB962C8B-B14F-4D97-AF65-F5344CB8AC3E}">
@@ -22424,6 +22595,42 @@
           </a:p>
         </p:txBody>
       </p:sp>
+      <p:sp>
+        <p:nvSpPr>
+          <p:cNvPr id="4" name="TextBox 3">
+            <a:extLst>
+              <a:ext uri="{FF2B5EF4-FFF2-40B4-BE49-F238E27FC236}">
+                <a16:creationId xmlns:a16="http://schemas.microsoft.com/office/drawing/2014/main" id="{8D529519-186C-CEFA-E7F6-FFCAEFA27EC8}"/>
+              </a:ext>
+            </a:extLst>
+          </p:cNvPr>
+          <p:cNvSpPr txBox="1"/>
+          <p:nvPr/>
+        </p:nvSpPr>
+        <p:spPr>
+          <a:xfrm>
+            <a:off x="9619967" y="6471982"/>
+            <a:ext cx="2499246" cy="307777"/>
+          </a:xfrm>
+          <a:prstGeom prst="rect">
+            <a:avLst/>
+          </a:prstGeom>
+          <a:noFill/>
+        </p:spPr>
+        <p:txBody>
+          <a:bodyPr wrap="square">
+            <a:spAutoFit/>
+          </a:bodyPr>
+          <a:lstStyle/>
+          <a:p>
+            <a:pPr algn="r"/>
+            <a:r>
+              <a:rPr lang="en-US" sz="1400" dirty="0"/>
+              <a:t>D: checkout file.</a:t>
+            </a:r>
+          </a:p>
+        </p:txBody>
+      </p:sp>
     </p:spTree>
     <p:extLst>
       <p:ext uri="{BB962C8B-B14F-4D97-AF65-F5344CB8AC3E}">
@@ -22740,7 +22947,19 @@
               <a:rPr lang="nl-NL" sz="1800" noProof="0" dirty="0">
                 <a:cs typeface="Courier New" panose="02070309020205020404" pitchFamily="49" charset="0"/>
               </a:rPr>
-              <a:t> alle lokale wijzigingen terug!</a:t>
+              <a:t> alle lokale wijzigingen terug</a:t>
+            </a:r>
+            <a:r>
+              <a:rPr lang="nl-NL" sz="1800" dirty="0">
+                <a:cs typeface="Courier New" panose="02070309020205020404" pitchFamily="49" charset="0"/>
+              </a:rPr>
+              <a:t>; wijzigingen en verwijderingen</a:t>
+            </a:r>
+            <a:r>
+              <a:rPr lang="nl-NL" sz="1800" noProof="0" dirty="0">
+                <a:cs typeface="Courier New" panose="02070309020205020404" pitchFamily="49" charset="0"/>
+              </a:rPr>
+              <a:t>!</a:t>
             </a:r>
           </a:p>
           <a:p>
@@ -22752,7 +22971,13 @@
               <a:rPr lang="nl-NL" sz="1800" noProof="0" dirty="0">
                 <a:cs typeface="Courier New" panose="02070309020205020404" pitchFamily="49" charset="0"/>
               </a:rPr>
-              <a:t>Verwijdert nieuwe bestanden / brengt verwijderde bestanden terug.</a:t>
+              <a:t>Zet tijdslijn terug </a:t>
+            </a:r>
+            <a:r>
+              <a:rPr lang="nl-NL" sz="1800" dirty="0">
+                <a:cs typeface="Courier New" panose="02070309020205020404" pitchFamily="49" charset="0"/>
+              </a:rPr>
+              <a:t>naar opgegeven commit.</a:t>
             </a:r>
           </a:p>
           <a:p>
@@ -22764,7 +22989,7 @@
               <a:rPr lang="nl-NL" sz="1800" noProof="0" dirty="0">
                 <a:cs typeface="Courier New" panose="02070309020205020404" pitchFamily="49" charset="0"/>
               </a:rPr>
-              <a:t>Zet tijdslijn terug en ontkoppelt nieuwe </a:t>
+              <a:t>Latere </a:t>
             </a:r>
             <a:r>
               <a:rPr lang="nl-NL" sz="1800" noProof="0" dirty="0" err="1">
@@ -22776,7 +23001,43 @@
               <a:rPr lang="nl-NL" sz="1800" noProof="0" dirty="0">
                 <a:cs typeface="Courier New" panose="02070309020205020404" pitchFamily="49" charset="0"/>
               </a:rPr>
-              <a:t>!</a:t>
+              <a:t> niet meer zichtbaar in log!</a:t>
+            </a:r>
+          </a:p>
+        </p:txBody>
+      </p:sp>
+      <p:sp>
+        <p:nvSpPr>
+          <p:cNvPr id="4" name="TextBox 3">
+            <a:extLst>
+              <a:ext uri="{FF2B5EF4-FFF2-40B4-BE49-F238E27FC236}">
+                <a16:creationId xmlns:a16="http://schemas.microsoft.com/office/drawing/2014/main" id="{0A9C5190-E353-73AF-78EB-042760983320}"/>
+              </a:ext>
+            </a:extLst>
+          </p:cNvPr>
+          <p:cNvSpPr txBox="1"/>
+          <p:nvPr/>
+        </p:nvSpPr>
+        <p:spPr>
+          <a:xfrm>
+            <a:off x="9619967" y="6471982"/>
+            <a:ext cx="2499246" cy="307777"/>
+          </a:xfrm>
+          <a:prstGeom prst="rect">
+            <a:avLst/>
+          </a:prstGeom>
+          <a:noFill/>
+        </p:spPr>
+        <p:txBody>
+          <a:bodyPr wrap="square">
+            <a:spAutoFit/>
+          </a:bodyPr>
+          <a:lstStyle/>
+          <a:p>
+            <a:pPr algn="r"/>
+            <a:r>
+              <a:rPr lang="en-US" sz="1400" dirty="0"/>
+              <a:t>D: reset hard.</a:t>
             </a:r>
           </a:p>
         </p:txBody>
@@ -23047,22 +23308,17 @@
             </a:r>
             <a:r>
               <a:rPr lang="nl-NL" sz="1800" noProof="0" dirty="0" err="1">
+                <a:latin typeface="Courier New" panose="02070309020205020404" pitchFamily="49" charset="0"/>
                 <a:cs typeface="Courier New" panose="02070309020205020404" pitchFamily="49" charset="0"/>
               </a:rPr>
               <a:t>detached</a:t>
-            </a:r>
-            <a:r>
-              <a:rPr lang="nl-NL" sz="1800" noProof="0" dirty="0">
-                <a:cs typeface="Courier New" panose="02070309020205020404" pitchFamily="49" charset="0"/>
-              </a:rPr>
-              <a:t> </a:t>
             </a:r>
             <a:r>
               <a:rPr lang="nl-NL" sz="1800" noProof="0" dirty="0">
                 <a:latin typeface="Courier New" panose="02070309020205020404" pitchFamily="49" charset="0"/>
                 <a:cs typeface="Courier New" panose="02070309020205020404" pitchFamily="49" charset="0"/>
               </a:rPr>
-              <a:t>HEAD</a:t>
+              <a:t> HEAD</a:t>
             </a:r>
             <a:r>
               <a:rPr lang="nl-NL" sz="1800" noProof="0" dirty="0">
@@ -23070,6 +23326,47 @@
               </a:rPr>
               <a:t>.</a:t>
             </a:r>
+          </a:p>
+        </p:txBody>
+      </p:sp>
+      <p:sp>
+        <p:nvSpPr>
+          <p:cNvPr id="4" name="TextBox 3">
+            <a:extLst>
+              <a:ext uri="{FF2B5EF4-FFF2-40B4-BE49-F238E27FC236}">
+                <a16:creationId xmlns:a16="http://schemas.microsoft.com/office/drawing/2014/main" id="{9BBCF973-7E0E-CB82-C930-C5610DEC8AC4}"/>
+              </a:ext>
+            </a:extLst>
+          </p:cNvPr>
+          <p:cNvSpPr txBox="1"/>
+          <p:nvPr/>
+        </p:nvSpPr>
+        <p:spPr>
+          <a:xfrm>
+            <a:off x="9619967" y="6471982"/>
+            <a:ext cx="2499246" cy="307777"/>
+          </a:xfrm>
+          <a:prstGeom prst="rect">
+            <a:avLst/>
+          </a:prstGeom>
+          <a:noFill/>
+        </p:spPr>
+        <p:txBody>
+          <a:bodyPr wrap="square">
+            <a:spAutoFit/>
+          </a:bodyPr>
+          <a:lstStyle/>
+          <a:p>
+            <a:pPr algn="r"/>
+            <a:r>
+              <a:rPr lang="en-US" sz="1400" dirty="0"/>
+              <a:t>D: </a:t>
+            </a:r>
+            <a:r>
+              <a:rPr lang="en-US" sz="1400"/>
+              <a:t>checkout commit.</a:t>
+            </a:r>
+            <a:endParaRPr lang="en-US" sz="1400" dirty="0"/>
           </a:p>
         </p:txBody>
       </p:sp>
@@ -23176,6 +23473,384 @@
 </file>
 
 <file path=ppt/slides/slide33.xml><?xml version="1.0" encoding="utf-8"?>
+<p:sld xmlns:a="http://schemas.openxmlformats.org/drawingml/2006/main" xmlns:r="http://schemas.openxmlformats.org/officeDocument/2006/relationships" xmlns:p="http://schemas.openxmlformats.org/presentationml/2006/main">
+  <p:cSld>
+    <p:spTree>
+      <p:nvGrpSpPr>
+        <p:cNvPr id="1" name="">
+          <a:extLst>
+            <a:ext uri="{FF2B5EF4-FFF2-40B4-BE49-F238E27FC236}">
+              <a16:creationId xmlns:a16="http://schemas.microsoft.com/office/drawing/2014/main" id="{2FB4C1BC-9822-0476-7BD0-4E4AF83B63AB}"/>
+            </a:ext>
+          </a:extLst>
+        </p:cNvPr>
+        <p:cNvGrpSpPr/>
+        <p:nvPr/>
+      </p:nvGrpSpPr>
+      <p:grpSpPr>
+        <a:xfrm>
+          <a:off x="0" y="0"/>
+          <a:ext cx="0" cy="0"/>
+          <a:chOff x="0" y="0"/>
+          <a:chExt cx="0" cy="0"/>
+        </a:xfrm>
+      </p:grpSpPr>
+      <p:sp>
+        <p:nvSpPr>
+          <p:cNvPr id="2" name="Title 1">
+            <a:extLst>
+              <a:ext uri="{FF2B5EF4-FFF2-40B4-BE49-F238E27FC236}">
+                <a16:creationId xmlns:a16="http://schemas.microsoft.com/office/drawing/2014/main" id="{A5C6DBF1-CC17-1B2E-A538-E8E41BBE4ADA}"/>
+              </a:ext>
+            </a:extLst>
+          </p:cNvPr>
+          <p:cNvSpPr>
+            <a:spLocks noGrp="1"/>
+          </p:cNvSpPr>
+          <p:nvPr>
+            <p:ph type="title"/>
+          </p:nvPr>
+        </p:nvSpPr>
+        <p:spPr>
+          <a:xfrm>
+            <a:off x="838200" y="365126"/>
+            <a:ext cx="10515600" cy="718608"/>
+          </a:xfrm>
+        </p:spPr>
+        <p:txBody>
+          <a:bodyPr>
+            <a:normAutofit/>
+          </a:bodyPr>
+          <a:lstStyle/>
+          <a:p>
+            <a:r>
+              <a:rPr lang="nl-NL" sz="3600" noProof="0" dirty="0"/>
+              <a:t>Branches</a:t>
+            </a:r>
+          </a:p>
+        </p:txBody>
+      </p:sp>
+      <p:grpSp>
+        <p:nvGrpSpPr>
+          <p:cNvPr id="4" name="Group 3">
+            <a:extLst>
+              <a:ext uri="{FF2B5EF4-FFF2-40B4-BE49-F238E27FC236}">
+                <a16:creationId xmlns:a16="http://schemas.microsoft.com/office/drawing/2014/main" id="{347AE867-F0BA-BF52-81AE-D854DF125FF3}"/>
+              </a:ext>
+            </a:extLst>
+          </p:cNvPr>
+          <p:cNvGrpSpPr/>
+          <p:nvPr/>
+        </p:nvGrpSpPr>
+        <p:grpSpPr>
+          <a:xfrm>
+            <a:off x="838200" y="3238594"/>
+            <a:ext cx="5984463" cy="322208"/>
+            <a:chOff x="1654294" y="2795457"/>
+            <a:chExt cx="5984463" cy="322208"/>
+          </a:xfrm>
+        </p:grpSpPr>
+        <p:cxnSp>
+          <p:nvCxnSpPr>
+            <p:cNvPr id="5" name="Straight Arrow Connector 4">
+              <a:extLst>
+                <a:ext uri="{FF2B5EF4-FFF2-40B4-BE49-F238E27FC236}">
+                  <a16:creationId xmlns:a16="http://schemas.microsoft.com/office/drawing/2014/main" id="{C4E4CEF5-DC10-5CF7-BF29-53248DB910FD}"/>
+                </a:ext>
+              </a:extLst>
+            </p:cNvPr>
+            <p:cNvCxnSpPr>
+              <a:cxnSpLocks/>
+            </p:cNvCxnSpPr>
+            <p:nvPr/>
+          </p:nvCxnSpPr>
+          <p:spPr>
+            <a:xfrm>
+              <a:off x="1654294" y="2956562"/>
+              <a:ext cx="5984463" cy="0"/>
+            </a:xfrm>
+            <a:prstGeom prst="straightConnector1">
+              <a:avLst/>
+            </a:prstGeom>
+            <a:ln>
+              <a:tailEnd type="triangle"/>
+            </a:ln>
+          </p:spPr>
+          <p:style>
+            <a:lnRef idx="3">
+              <a:schemeClr val="dk1"/>
+            </a:lnRef>
+            <a:fillRef idx="0">
+              <a:schemeClr val="dk1"/>
+            </a:fillRef>
+            <a:effectRef idx="2">
+              <a:schemeClr val="dk1"/>
+            </a:effectRef>
+            <a:fontRef idx="minor">
+              <a:schemeClr val="tx1"/>
+            </a:fontRef>
+          </p:style>
+        </p:cxnSp>
+        <p:sp>
+          <p:nvSpPr>
+            <p:cNvPr id="56" name="Oval 55">
+              <a:extLst>
+                <a:ext uri="{FF2B5EF4-FFF2-40B4-BE49-F238E27FC236}">
+                  <a16:creationId xmlns:a16="http://schemas.microsoft.com/office/drawing/2014/main" id="{D76FF1F7-EFB6-B7E9-7886-AD96B763EB85}"/>
+                </a:ext>
+              </a:extLst>
+            </p:cNvPr>
+            <p:cNvSpPr/>
+            <p:nvPr/>
+          </p:nvSpPr>
+          <p:spPr>
+            <a:xfrm>
+              <a:off x="2471339" y="2795458"/>
+              <a:ext cx="323160" cy="322207"/>
+            </a:xfrm>
+            <a:prstGeom prst="ellipse">
+              <a:avLst/>
+            </a:prstGeom>
+          </p:spPr>
+          <p:style>
+            <a:lnRef idx="2">
+              <a:schemeClr val="dk1"/>
+            </a:lnRef>
+            <a:fillRef idx="1">
+              <a:schemeClr val="lt1"/>
+            </a:fillRef>
+            <a:effectRef idx="0">
+              <a:schemeClr val="dk1"/>
+            </a:effectRef>
+            <a:fontRef idx="minor">
+              <a:schemeClr val="dk1"/>
+            </a:fontRef>
+          </p:style>
+          <p:txBody>
+            <a:bodyPr rtlCol="0" anchor="ctr"/>
+            <a:lstStyle/>
+            <a:p>
+              <a:pPr algn="ctr"/>
+              <a:r>
+                <a:rPr lang="nl-NL" noProof="0" dirty="0"/>
+                <a:t>C</a:t>
+              </a:r>
+            </a:p>
+          </p:txBody>
+        </p:sp>
+        <p:sp>
+          <p:nvSpPr>
+            <p:cNvPr id="57" name="Oval 56">
+              <a:extLst>
+                <a:ext uri="{FF2B5EF4-FFF2-40B4-BE49-F238E27FC236}">
+                  <a16:creationId xmlns:a16="http://schemas.microsoft.com/office/drawing/2014/main" id="{A0F886C9-1865-31D8-05F1-AE059FA89797}"/>
+                </a:ext>
+              </a:extLst>
+            </p:cNvPr>
+            <p:cNvSpPr/>
+            <p:nvPr/>
+          </p:nvSpPr>
+          <p:spPr>
+            <a:xfrm>
+              <a:off x="4484945" y="2795457"/>
+              <a:ext cx="323160" cy="322207"/>
+            </a:xfrm>
+            <a:prstGeom prst="ellipse">
+              <a:avLst/>
+            </a:prstGeom>
+            <a:solidFill>
+              <a:schemeClr val="accent6">
+                <a:lumMod val="40000"/>
+                <a:lumOff val="60000"/>
+              </a:schemeClr>
+            </a:solidFill>
+          </p:spPr>
+          <p:style>
+            <a:lnRef idx="2">
+              <a:schemeClr val="dk1"/>
+            </a:lnRef>
+            <a:fillRef idx="1">
+              <a:schemeClr val="lt1"/>
+            </a:fillRef>
+            <a:effectRef idx="0">
+              <a:schemeClr val="dk1"/>
+            </a:effectRef>
+            <a:fontRef idx="minor">
+              <a:schemeClr val="dk1"/>
+            </a:fontRef>
+          </p:style>
+          <p:txBody>
+            <a:bodyPr rtlCol="0" anchor="ctr"/>
+            <a:lstStyle/>
+            <a:p>
+              <a:pPr algn="ctr"/>
+              <a:r>
+                <a:rPr lang="nl-NL" noProof="0" dirty="0"/>
+                <a:t>C</a:t>
+              </a:r>
+            </a:p>
+          </p:txBody>
+        </p:sp>
+      </p:grpSp>
+      <p:cxnSp>
+        <p:nvCxnSpPr>
+          <p:cNvPr id="6" name="Connector: Curved 5">
+            <a:extLst>
+              <a:ext uri="{FF2B5EF4-FFF2-40B4-BE49-F238E27FC236}">
+                <a16:creationId xmlns:a16="http://schemas.microsoft.com/office/drawing/2014/main" id="{D7A211F4-68EC-8EC9-26B6-8AAAF3B038CA}"/>
+              </a:ext>
+            </a:extLst>
+          </p:cNvPr>
+          <p:cNvCxnSpPr>
+            <a:cxnSpLocks/>
+          </p:cNvCxnSpPr>
+          <p:nvPr/>
+        </p:nvCxnSpPr>
+        <p:spPr>
+          <a:xfrm rot="5400000">
+            <a:off x="2825553" y="2634548"/>
+            <a:ext cx="1" cy="2013606"/>
+          </a:xfrm>
+          <a:prstGeom prst="curvedConnector3">
+            <a:avLst>
+              <a:gd name="adj1" fmla="val 22860100000"/>
+            </a:avLst>
+          </a:prstGeom>
+          <a:ln>
+            <a:tailEnd type="triangle"/>
+          </a:ln>
+        </p:spPr>
+        <p:style>
+          <a:lnRef idx="2">
+            <a:schemeClr val="dk1"/>
+          </a:lnRef>
+          <a:fillRef idx="0">
+            <a:schemeClr val="dk1"/>
+          </a:fillRef>
+          <a:effectRef idx="1">
+            <a:schemeClr val="dk1"/>
+          </a:effectRef>
+          <a:fontRef idx="minor">
+            <a:schemeClr val="tx1"/>
+          </a:fontRef>
+        </p:style>
+      </p:cxnSp>
+      <p:sp>
+        <p:nvSpPr>
+          <p:cNvPr id="20" name="Rectangle 19">
+            <a:extLst>
+              <a:ext uri="{FF2B5EF4-FFF2-40B4-BE49-F238E27FC236}">
+                <a16:creationId xmlns:a16="http://schemas.microsoft.com/office/drawing/2014/main" id="{5C467A90-639D-1E76-4BF8-FD5694BFFB91}"/>
+              </a:ext>
+            </a:extLst>
+          </p:cNvPr>
+          <p:cNvSpPr/>
+          <p:nvPr/>
+        </p:nvSpPr>
+        <p:spPr>
+          <a:xfrm>
+            <a:off x="1612214" y="4136941"/>
+            <a:ext cx="2426677" cy="1033976"/>
+          </a:xfrm>
+          <a:prstGeom prst="rect">
+            <a:avLst/>
+          </a:prstGeom>
+          <a:solidFill>
+            <a:schemeClr val="accent4">
+              <a:lumMod val="20000"/>
+              <a:lumOff val="80000"/>
+            </a:schemeClr>
+          </a:solidFill>
+          <a:ln>
+            <a:solidFill>
+              <a:schemeClr val="accent4">
+                <a:lumMod val="60000"/>
+                <a:lumOff val="40000"/>
+              </a:schemeClr>
+            </a:solidFill>
+          </a:ln>
+        </p:spPr>
+        <p:style>
+          <a:lnRef idx="2">
+            <a:schemeClr val="accent1">
+              <a:shade val="15000"/>
+            </a:schemeClr>
+          </a:lnRef>
+          <a:fillRef idx="1">
+            <a:schemeClr val="accent1"/>
+          </a:fillRef>
+          <a:effectRef idx="0">
+            <a:schemeClr val="accent1"/>
+          </a:effectRef>
+          <a:fontRef idx="minor">
+            <a:schemeClr val="lt1"/>
+          </a:fontRef>
+        </p:style>
+        <p:txBody>
+          <a:bodyPr rtlCol="0" anchor="ctr"/>
+          <a:lstStyle/>
+          <a:p>
+            <a:pPr algn="ctr"/>
+            <a:r>
+              <a:rPr lang="nl-NL" noProof="0" dirty="0" err="1">
+                <a:solidFill>
+                  <a:sysClr val="windowText" lastClr="000000"/>
+                </a:solidFill>
+              </a:rPr>
+              <a:t>Commits</a:t>
+            </a:r>
+            <a:r>
+              <a:rPr lang="nl-NL" noProof="0" dirty="0">
+                <a:solidFill>
+                  <a:sysClr val="windowText" lastClr="000000"/>
+                </a:solidFill>
+              </a:rPr>
+              <a:t> houden</a:t>
+            </a:r>
+          </a:p>
+          <a:p>
+            <a:pPr algn="ctr"/>
+            <a:r>
+              <a:rPr lang="nl-NL" noProof="0" dirty="0">
+                <a:solidFill>
+                  <a:sysClr val="windowText" lastClr="000000"/>
+                </a:solidFill>
+              </a:rPr>
+              <a:t>zelf </a:t>
+            </a:r>
+            <a:r>
+              <a:rPr lang="nl-NL" noProof="0" dirty="0" err="1">
+                <a:solidFill>
+                  <a:sysClr val="windowText" lastClr="000000"/>
+                </a:solidFill>
+              </a:rPr>
+              <a:t>parent</a:t>
+            </a:r>
+            <a:r>
+              <a:rPr lang="nl-NL" noProof="0" dirty="0">
+                <a:solidFill>
+                  <a:sysClr val="windowText" lastClr="000000"/>
+                </a:solidFill>
+              </a:rPr>
+              <a:t> bij</a:t>
+            </a:r>
+          </a:p>
+        </p:txBody>
+      </p:sp>
+    </p:spTree>
+    <p:extLst>
+      <p:ext uri="{BB962C8B-B14F-4D97-AF65-F5344CB8AC3E}">
+        <p14:creationId xmlns:p14="http://schemas.microsoft.com/office/powerpoint/2010/main" val="3946550789"/>
+      </p:ext>
+    </p:extLst>
+  </p:cSld>
+  <p:clrMapOvr>
+    <a:masterClrMapping/>
+  </p:clrMapOvr>
+</p:sld>
+</file>
+
+<file path=ppt/slides/slide34.xml><?xml version="1.0" encoding="utf-8"?>
 <p:sld xmlns:a="http://schemas.openxmlformats.org/drawingml/2006/main" xmlns:r="http://schemas.openxmlformats.org/officeDocument/2006/relationships" xmlns:p="http://schemas.openxmlformats.org/presentationml/2006/main">
   <p:cSld>
     <p:spTree>
@@ -23474,6 +24149,49 @@
           </a:fontRef>
         </p:style>
       </p:cxnSp>
+      <p:cxnSp>
+        <p:nvCxnSpPr>
+          <p:cNvPr id="6" name="Connector: Curved 5">
+            <a:extLst>
+              <a:ext uri="{FF2B5EF4-FFF2-40B4-BE49-F238E27FC236}">
+                <a16:creationId xmlns:a16="http://schemas.microsoft.com/office/drawing/2014/main" id="{7C3D9F5A-BC6A-368E-9B62-2402292E3481}"/>
+              </a:ext>
+            </a:extLst>
+          </p:cNvPr>
+          <p:cNvCxnSpPr>
+            <a:cxnSpLocks/>
+          </p:cNvCxnSpPr>
+          <p:nvPr/>
+        </p:nvCxnSpPr>
+        <p:spPr>
+          <a:xfrm rot="5400000">
+            <a:off x="2825553" y="2634548"/>
+            <a:ext cx="1" cy="2013606"/>
+          </a:xfrm>
+          <a:prstGeom prst="curvedConnector3">
+            <a:avLst>
+              <a:gd name="adj1" fmla="val 22860100000"/>
+            </a:avLst>
+          </a:prstGeom>
+          <a:ln>
+            <a:tailEnd type="triangle"/>
+          </a:ln>
+        </p:spPr>
+        <p:style>
+          <a:lnRef idx="2">
+            <a:schemeClr val="dk1"/>
+          </a:lnRef>
+          <a:fillRef idx="0">
+            <a:schemeClr val="dk1"/>
+          </a:fillRef>
+          <a:effectRef idx="1">
+            <a:schemeClr val="dk1"/>
+          </a:effectRef>
+          <a:fontRef idx="minor">
+            <a:schemeClr val="tx1"/>
+          </a:fontRef>
+        </p:style>
+      </p:cxnSp>
     </p:spTree>
     <p:extLst>
       <p:ext uri="{BB962C8B-B14F-4D97-AF65-F5344CB8AC3E}">
@@ -23487,7 +24205,7 @@
 </p:sld>
 </file>
 
-<file path=ppt/slides/slide34.xml><?xml version="1.0" encoding="utf-8"?>
+<file path=ppt/slides/slide35.xml><?xml version="1.0" encoding="utf-8"?>
 <p:sld xmlns:a="http://schemas.openxmlformats.org/drawingml/2006/main" xmlns:r="http://schemas.openxmlformats.org/officeDocument/2006/relationships" xmlns:p="http://schemas.openxmlformats.org/presentationml/2006/main">
   <p:cSld>
     <p:spTree>
@@ -23928,993 +24646,12 @@
           </a:fontRef>
         </p:style>
       </p:cxnSp>
-    </p:spTree>
-    <p:extLst>
-      <p:ext uri="{BB962C8B-B14F-4D97-AF65-F5344CB8AC3E}">
-        <p14:creationId xmlns:p14="http://schemas.microsoft.com/office/powerpoint/2010/main" val="458030483"/>
-      </p:ext>
-    </p:extLst>
-  </p:cSld>
-  <p:clrMapOvr>
-    <a:masterClrMapping/>
-  </p:clrMapOvr>
-</p:sld>
-</file>
-
-<file path=ppt/slides/slide35.xml><?xml version="1.0" encoding="utf-8"?>
-<p:sld xmlns:a="http://schemas.openxmlformats.org/drawingml/2006/main" xmlns:r="http://schemas.openxmlformats.org/officeDocument/2006/relationships" xmlns:p="http://schemas.openxmlformats.org/presentationml/2006/main">
-  <p:cSld>
-    <p:spTree>
-      <p:nvGrpSpPr>
-        <p:cNvPr id="1" name="">
-          <a:extLst>
-            <a:ext uri="{FF2B5EF4-FFF2-40B4-BE49-F238E27FC236}">
-              <a16:creationId xmlns:a16="http://schemas.microsoft.com/office/drawing/2014/main" id="{2FB4C1BC-9822-0476-7BD0-4E4AF83B63AB}"/>
-            </a:ext>
-          </a:extLst>
-        </p:cNvPr>
-        <p:cNvGrpSpPr/>
-        <p:nvPr/>
-      </p:nvGrpSpPr>
-      <p:grpSpPr>
-        <a:xfrm>
-          <a:off x="0" y="0"/>
-          <a:ext cx="0" cy="0"/>
-          <a:chOff x="0" y="0"/>
-          <a:chExt cx="0" cy="0"/>
-        </a:xfrm>
-      </p:grpSpPr>
-      <p:sp>
-        <p:nvSpPr>
-          <p:cNvPr id="2" name="Title 1">
-            <a:extLst>
-              <a:ext uri="{FF2B5EF4-FFF2-40B4-BE49-F238E27FC236}">
-                <a16:creationId xmlns:a16="http://schemas.microsoft.com/office/drawing/2014/main" id="{A5C6DBF1-CC17-1B2E-A538-E8E41BBE4ADA}"/>
-              </a:ext>
-            </a:extLst>
-          </p:cNvPr>
-          <p:cNvSpPr>
-            <a:spLocks noGrp="1"/>
-          </p:cNvSpPr>
-          <p:nvPr>
-            <p:ph type="title"/>
-          </p:nvPr>
-        </p:nvSpPr>
-        <p:spPr>
-          <a:xfrm>
-            <a:off x="838200" y="365126"/>
-            <a:ext cx="10515600" cy="718608"/>
-          </a:xfrm>
-        </p:spPr>
-        <p:txBody>
-          <a:bodyPr>
-            <a:normAutofit/>
-          </a:bodyPr>
-          <a:lstStyle/>
-          <a:p>
-            <a:r>
-              <a:rPr lang="nl-NL" sz="3600" noProof="0" dirty="0"/>
-              <a:t>Branches</a:t>
-            </a:r>
-          </a:p>
-        </p:txBody>
-      </p:sp>
-      <p:grpSp>
-        <p:nvGrpSpPr>
-          <p:cNvPr id="4" name="Group 3">
-            <a:extLst>
-              <a:ext uri="{FF2B5EF4-FFF2-40B4-BE49-F238E27FC236}">
-                <a16:creationId xmlns:a16="http://schemas.microsoft.com/office/drawing/2014/main" id="{347AE867-F0BA-BF52-81AE-D854DF125FF3}"/>
-              </a:ext>
-            </a:extLst>
-          </p:cNvPr>
-          <p:cNvGrpSpPr/>
-          <p:nvPr/>
-        </p:nvGrpSpPr>
-        <p:grpSpPr>
-          <a:xfrm>
-            <a:off x="838200" y="3238594"/>
-            <a:ext cx="5984463" cy="322208"/>
-            <a:chOff x="1654294" y="2795457"/>
-            <a:chExt cx="5984463" cy="322208"/>
-          </a:xfrm>
-        </p:grpSpPr>
-        <p:cxnSp>
-          <p:nvCxnSpPr>
-            <p:cNvPr id="5" name="Straight Arrow Connector 4">
-              <a:extLst>
-                <a:ext uri="{FF2B5EF4-FFF2-40B4-BE49-F238E27FC236}">
-                  <a16:creationId xmlns:a16="http://schemas.microsoft.com/office/drawing/2014/main" id="{C4E4CEF5-DC10-5CF7-BF29-53248DB910FD}"/>
-                </a:ext>
-              </a:extLst>
-            </p:cNvPr>
-            <p:cNvCxnSpPr>
-              <a:cxnSpLocks/>
-            </p:cNvCxnSpPr>
-            <p:nvPr/>
-          </p:nvCxnSpPr>
-          <p:spPr>
-            <a:xfrm>
-              <a:off x="1654294" y="2956562"/>
-              <a:ext cx="5984463" cy="0"/>
-            </a:xfrm>
-            <a:prstGeom prst="straightConnector1">
-              <a:avLst/>
-            </a:prstGeom>
-            <a:ln>
-              <a:tailEnd type="triangle"/>
-            </a:ln>
-          </p:spPr>
-          <p:style>
-            <a:lnRef idx="3">
-              <a:schemeClr val="dk1"/>
-            </a:lnRef>
-            <a:fillRef idx="0">
-              <a:schemeClr val="dk1"/>
-            </a:fillRef>
-            <a:effectRef idx="2">
-              <a:schemeClr val="dk1"/>
-            </a:effectRef>
-            <a:fontRef idx="minor">
-              <a:schemeClr val="tx1"/>
-            </a:fontRef>
-          </p:style>
-        </p:cxnSp>
-        <p:sp>
-          <p:nvSpPr>
-            <p:cNvPr id="56" name="Oval 55">
-              <a:extLst>
-                <a:ext uri="{FF2B5EF4-FFF2-40B4-BE49-F238E27FC236}">
-                  <a16:creationId xmlns:a16="http://schemas.microsoft.com/office/drawing/2014/main" id="{D76FF1F7-EFB6-B7E9-7886-AD96B763EB85}"/>
-                </a:ext>
-              </a:extLst>
-            </p:cNvPr>
-            <p:cNvSpPr/>
-            <p:nvPr/>
-          </p:nvSpPr>
-          <p:spPr>
-            <a:xfrm>
-              <a:off x="2471339" y="2795458"/>
-              <a:ext cx="323160" cy="322207"/>
-            </a:xfrm>
-            <a:prstGeom prst="ellipse">
-              <a:avLst/>
-            </a:prstGeom>
-          </p:spPr>
-          <p:style>
-            <a:lnRef idx="2">
-              <a:schemeClr val="dk1"/>
-            </a:lnRef>
-            <a:fillRef idx="1">
-              <a:schemeClr val="lt1"/>
-            </a:fillRef>
-            <a:effectRef idx="0">
-              <a:schemeClr val="dk1"/>
-            </a:effectRef>
-            <a:fontRef idx="minor">
-              <a:schemeClr val="dk1"/>
-            </a:fontRef>
-          </p:style>
-          <p:txBody>
-            <a:bodyPr rtlCol="0" anchor="ctr"/>
-            <a:lstStyle/>
-            <a:p>
-              <a:pPr algn="ctr"/>
-              <a:r>
-                <a:rPr lang="nl-NL" noProof="0" dirty="0"/>
-                <a:t>C</a:t>
-              </a:r>
-            </a:p>
-          </p:txBody>
-        </p:sp>
-        <p:sp>
-          <p:nvSpPr>
-            <p:cNvPr id="57" name="Oval 56">
-              <a:extLst>
-                <a:ext uri="{FF2B5EF4-FFF2-40B4-BE49-F238E27FC236}">
-                  <a16:creationId xmlns:a16="http://schemas.microsoft.com/office/drawing/2014/main" id="{A0F886C9-1865-31D8-05F1-AE059FA89797}"/>
-                </a:ext>
-              </a:extLst>
-            </p:cNvPr>
-            <p:cNvSpPr/>
-            <p:nvPr/>
-          </p:nvSpPr>
-          <p:spPr>
-            <a:xfrm>
-              <a:off x="4484945" y="2795457"/>
-              <a:ext cx="323160" cy="322207"/>
-            </a:xfrm>
-            <a:prstGeom prst="ellipse">
-              <a:avLst/>
-            </a:prstGeom>
-            <a:solidFill>
-              <a:schemeClr val="accent6">
-                <a:lumMod val="40000"/>
-                <a:lumOff val="60000"/>
-              </a:schemeClr>
-            </a:solidFill>
-          </p:spPr>
-          <p:style>
-            <a:lnRef idx="2">
-              <a:schemeClr val="dk1"/>
-            </a:lnRef>
-            <a:fillRef idx="1">
-              <a:schemeClr val="lt1"/>
-            </a:fillRef>
-            <a:effectRef idx="0">
-              <a:schemeClr val="dk1"/>
-            </a:effectRef>
-            <a:fontRef idx="minor">
-              <a:schemeClr val="dk1"/>
-            </a:fontRef>
-          </p:style>
-          <p:txBody>
-            <a:bodyPr rtlCol="0" anchor="ctr"/>
-            <a:lstStyle/>
-            <a:p>
-              <a:pPr algn="ctr"/>
-              <a:r>
-                <a:rPr lang="nl-NL" noProof="0" dirty="0"/>
-                <a:t>C</a:t>
-              </a:r>
-            </a:p>
-          </p:txBody>
-        </p:sp>
-      </p:grpSp>
-      <p:sp>
-        <p:nvSpPr>
-          <p:cNvPr id="8" name="TextBox 7">
-            <a:extLst>
-              <a:ext uri="{FF2B5EF4-FFF2-40B4-BE49-F238E27FC236}">
-                <a16:creationId xmlns:a16="http://schemas.microsoft.com/office/drawing/2014/main" id="{34CF3F4B-D03D-41EE-C314-0BEE8D1E5ACA}"/>
-              </a:ext>
-            </a:extLst>
-          </p:cNvPr>
-          <p:cNvSpPr txBox="1"/>
-          <p:nvPr/>
-        </p:nvSpPr>
-        <p:spPr>
-          <a:xfrm>
-            <a:off x="2611984" y="2262344"/>
-            <a:ext cx="2426677" cy="400110"/>
-          </a:xfrm>
-          <a:prstGeom prst="rect">
-            <a:avLst/>
-          </a:prstGeom>
-          <a:noFill/>
-        </p:spPr>
-        <p:txBody>
-          <a:bodyPr wrap="square" rtlCol="0">
-            <a:spAutoFit/>
-          </a:bodyPr>
-          <a:lstStyle/>
-          <a:p>
-            <a:pPr algn="r"/>
-            <a:r>
-              <a:rPr lang="nl-NL" sz="2000" noProof="0" dirty="0"/>
-              <a:t>.git/refs/</a:t>
-            </a:r>
-            <a:r>
-              <a:rPr lang="nl-NL" sz="2000" noProof="0" dirty="0" err="1"/>
-              <a:t>heads</a:t>
-            </a:r>
-            <a:r>
-              <a:rPr lang="nl-NL" sz="2000" noProof="0" dirty="0"/>
-              <a:t>/</a:t>
-            </a:r>
-            <a:r>
-              <a:rPr lang="nl-NL" sz="2000" noProof="0" dirty="0" err="1"/>
-              <a:t>main</a:t>
-            </a:r>
-            <a:endParaRPr lang="nl-NL" sz="2000" noProof="0" dirty="0"/>
-          </a:p>
-        </p:txBody>
-      </p:sp>
       <p:cxnSp>
         <p:nvCxnSpPr>
-          <p:cNvPr id="9" name="Straight Arrow Connector 8">
-            <a:extLst>
-              <a:ext uri="{FF2B5EF4-FFF2-40B4-BE49-F238E27FC236}">
-                <a16:creationId xmlns:a16="http://schemas.microsoft.com/office/drawing/2014/main" id="{A100D1A7-64FB-3C80-9FD9-450CA61D9929}"/>
-              </a:ext>
-            </a:extLst>
-          </p:cNvPr>
-          <p:cNvCxnSpPr>
-            <a:cxnSpLocks/>
-          </p:cNvCxnSpPr>
-          <p:nvPr/>
-        </p:nvCxnSpPr>
-        <p:spPr>
-          <a:xfrm>
-            <a:off x="3832357" y="2662454"/>
-            <a:ext cx="0" cy="581253"/>
-          </a:xfrm>
-          <a:prstGeom prst="straightConnector1">
-            <a:avLst/>
-          </a:prstGeom>
-          <a:ln>
-            <a:tailEnd type="triangle"/>
-          </a:ln>
-        </p:spPr>
-        <p:style>
-          <a:lnRef idx="2">
-            <a:schemeClr val="dk1"/>
-          </a:lnRef>
-          <a:fillRef idx="0">
-            <a:schemeClr val="dk1"/>
-          </a:fillRef>
-          <a:effectRef idx="1">
-            <a:schemeClr val="dk1"/>
-          </a:effectRef>
-          <a:fontRef idx="minor">
-            <a:schemeClr val="tx1"/>
-          </a:fontRef>
-        </p:style>
-      </p:cxnSp>
-      <p:cxnSp>
-        <p:nvCxnSpPr>
-          <p:cNvPr id="6" name="Connector: Curved 5">
-            <a:extLst>
-              <a:ext uri="{FF2B5EF4-FFF2-40B4-BE49-F238E27FC236}">
-                <a16:creationId xmlns:a16="http://schemas.microsoft.com/office/drawing/2014/main" id="{D7A211F4-68EC-8EC9-26B6-8AAAF3B038CA}"/>
-              </a:ext>
-            </a:extLst>
-          </p:cNvPr>
-          <p:cNvCxnSpPr>
-            <a:cxnSpLocks/>
-          </p:cNvCxnSpPr>
-          <p:nvPr/>
-        </p:nvCxnSpPr>
-        <p:spPr>
-          <a:xfrm rot="5400000">
-            <a:off x="2825553" y="2634548"/>
-            <a:ext cx="1" cy="2013606"/>
-          </a:xfrm>
-          <a:prstGeom prst="curvedConnector3">
-            <a:avLst>
-              <a:gd name="adj1" fmla="val 22860100000"/>
-            </a:avLst>
-          </a:prstGeom>
-          <a:ln>
-            <a:tailEnd type="triangle"/>
-          </a:ln>
-        </p:spPr>
-        <p:style>
-          <a:lnRef idx="2">
-            <a:schemeClr val="dk1"/>
-          </a:lnRef>
-          <a:fillRef idx="0">
-            <a:schemeClr val="dk1"/>
-          </a:fillRef>
-          <a:effectRef idx="1">
-            <a:schemeClr val="dk1"/>
-          </a:effectRef>
-          <a:fontRef idx="minor">
-            <a:schemeClr val="tx1"/>
-          </a:fontRef>
-        </p:style>
-      </p:cxnSp>
-      <p:sp>
-        <p:nvSpPr>
-          <p:cNvPr id="20" name="Rectangle 19">
-            <a:extLst>
-              <a:ext uri="{FF2B5EF4-FFF2-40B4-BE49-F238E27FC236}">
-                <a16:creationId xmlns:a16="http://schemas.microsoft.com/office/drawing/2014/main" id="{5C467A90-639D-1E76-4BF8-FD5694BFFB91}"/>
-              </a:ext>
-            </a:extLst>
-          </p:cNvPr>
-          <p:cNvSpPr/>
-          <p:nvPr/>
-        </p:nvSpPr>
-        <p:spPr>
-          <a:xfrm>
-            <a:off x="1612214" y="4136941"/>
-            <a:ext cx="2426677" cy="1033976"/>
-          </a:xfrm>
-          <a:prstGeom prst="rect">
-            <a:avLst/>
-          </a:prstGeom>
-          <a:solidFill>
-            <a:schemeClr val="accent4">
-              <a:lumMod val="20000"/>
-              <a:lumOff val="80000"/>
-            </a:schemeClr>
-          </a:solidFill>
-          <a:ln>
-            <a:solidFill>
-              <a:schemeClr val="accent4">
-                <a:lumMod val="60000"/>
-                <a:lumOff val="40000"/>
-              </a:schemeClr>
-            </a:solidFill>
-          </a:ln>
-        </p:spPr>
-        <p:style>
-          <a:lnRef idx="2">
-            <a:schemeClr val="accent1">
-              <a:shade val="15000"/>
-            </a:schemeClr>
-          </a:lnRef>
-          <a:fillRef idx="1">
-            <a:schemeClr val="accent1"/>
-          </a:fillRef>
-          <a:effectRef idx="0">
-            <a:schemeClr val="accent1"/>
-          </a:effectRef>
-          <a:fontRef idx="minor">
-            <a:schemeClr val="lt1"/>
-          </a:fontRef>
-        </p:style>
-        <p:txBody>
-          <a:bodyPr rtlCol="0" anchor="ctr"/>
-          <a:lstStyle/>
-          <a:p>
-            <a:pPr algn="ctr"/>
-            <a:r>
-              <a:rPr lang="nl-NL" noProof="0" dirty="0" err="1">
-                <a:solidFill>
-                  <a:sysClr val="windowText" lastClr="000000"/>
-                </a:solidFill>
-              </a:rPr>
-              <a:t>Commits</a:t>
-            </a:r>
-            <a:r>
-              <a:rPr lang="nl-NL" noProof="0" dirty="0">
-                <a:solidFill>
-                  <a:sysClr val="windowText" lastClr="000000"/>
-                </a:solidFill>
-              </a:rPr>
-              <a:t> houden</a:t>
-            </a:r>
-          </a:p>
-          <a:p>
-            <a:pPr algn="ctr"/>
-            <a:r>
-              <a:rPr lang="nl-NL" noProof="0" dirty="0">
-                <a:solidFill>
-                  <a:sysClr val="windowText" lastClr="000000"/>
-                </a:solidFill>
-              </a:rPr>
-              <a:t>zelf </a:t>
-            </a:r>
-            <a:r>
-              <a:rPr lang="nl-NL" noProof="0" dirty="0" err="1">
-                <a:solidFill>
-                  <a:sysClr val="windowText" lastClr="000000"/>
-                </a:solidFill>
-              </a:rPr>
-              <a:t>parent</a:t>
-            </a:r>
-            <a:r>
-              <a:rPr lang="nl-NL" noProof="0" dirty="0">
-                <a:solidFill>
-                  <a:sysClr val="windowText" lastClr="000000"/>
-                </a:solidFill>
-              </a:rPr>
-              <a:t> bij</a:t>
-            </a:r>
-          </a:p>
-        </p:txBody>
-      </p:sp>
-    </p:spTree>
-    <p:extLst>
-      <p:ext uri="{BB962C8B-B14F-4D97-AF65-F5344CB8AC3E}">
-        <p14:creationId xmlns:p14="http://schemas.microsoft.com/office/powerpoint/2010/main" val="3946550789"/>
-      </p:ext>
-    </p:extLst>
-  </p:cSld>
-  <p:clrMapOvr>
-    <a:masterClrMapping/>
-  </p:clrMapOvr>
-</p:sld>
-</file>
-
-<file path=ppt/slides/slide36.xml><?xml version="1.0" encoding="utf-8"?>
-<p:sld xmlns:a="http://schemas.openxmlformats.org/drawingml/2006/main" xmlns:r="http://schemas.openxmlformats.org/officeDocument/2006/relationships" xmlns:p="http://schemas.openxmlformats.org/presentationml/2006/main">
-  <p:cSld>
-    <p:spTree>
-      <p:nvGrpSpPr>
-        <p:cNvPr id="1" name="">
-          <a:extLst>
-            <a:ext uri="{FF2B5EF4-FFF2-40B4-BE49-F238E27FC236}">
-              <a16:creationId xmlns:a16="http://schemas.microsoft.com/office/drawing/2014/main" id="{CEDB62F6-36B7-1607-1EB9-55521316B069}"/>
-            </a:ext>
-          </a:extLst>
-        </p:cNvPr>
-        <p:cNvGrpSpPr/>
-        <p:nvPr/>
-      </p:nvGrpSpPr>
-      <p:grpSpPr>
-        <a:xfrm>
-          <a:off x="0" y="0"/>
-          <a:ext cx="0" cy="0"/>
-          <a:chOff x="0" y="0"/>
-          <a:chExt cx="0" cy="0"/>
-        </a:xfrm>
-      </p:grpSpPr>
-      <p:sp>
-        <p:nvSpPr>
-          <p:cNvPr id="2" name="Title 1">
-            <a:extLst>
-              <a:ext uri="{FF2B5EF4-FFF2-40B4-BE49-F238E27FC236}">
-                <a16:creationId xmlns:a16="http://schemas.microsoft.com/office/drawing/2014/main" id="{2FC3ADF4-BD89-DC67-A664-857BC38D708C}"/>
-              </a:ext>
-            </a:extLst>
-          </p:cNvPr>
-          <p:cNvSpPr>
-            <a:spLocks noGrp="1"/>
-          </p:cNvSpPr>
-          <p:nvPr>
-            <p:ph type="title"/>
-          </p:nvPr>
-        </p:nvSpPr>
-        <p:spPr>
-          <a:xfrm>
-            <a:off x="838200" y="365126"/>
-            <a:ext cx="10515600" cy="718608"/>
-          </a:xfrm>
-        </p:spPr>
-        <p:txBody>
-          <a:bodyPr>
-            <a:normAutofit/>
-          </a:bodyPr>
-          <a:lstStyle/>
-          <a:p>
-            <a:r>
-              <a:rPr lang="nl-NL" sz="3600" noProof="0" dirty="0"/>
-              <a:t>Branches</a:t>
-            </a:r>
-          </a:p>
-        </p:txBody>
-      </p:sp>
-      <p:grpSp>
-        <p:nvGrpSpPr>
-          <p:cNvPr id="4" name="Group 3">
-            <a:extLst>
-              <a:ext uri="{FF2B5EF4-FFF2-40B4-BE49-F238E27FC236}">
-                <a16:creationId xmlns:a16="http://schemas.microsoft.com/office/drawing/2014/main" id="{7A0DA11A-BD12-BE4C-A19F-921D7FEE803D}"/>
-              </a:ext>
-            </a:extLst>
-          </p:cNvPr>
-          <p:cNvGrpSpPr/>
-          <p:nvPr/>
-        </p:nvGrpSpPr>
-        <p:grpSpPr>
-          <a:xfrm>
-            <a:off x="838200" y="3238594"/>
-            <a:ext cx="5984463" cy="322208"/>
-            <a:chOff x="1654294" y="2795457"/>
-            <a:chExt cx="5984463" cy="322208"/>
-          </a:xfrm>
-        </p:grpSpPr>
-        <p:cxnSp>
-          <p:nvCxnSpPr>
-            <p:cNvPr id="5" name="Straight Arrow Connector 4">
-              <a:extLst>
-                <a:ext uri="{FF2B5EF4-FFF2-40B4-BE49-F238E27FC236}">
-                  <a16:creationId xmlns:a16="http://schemas.microsoft.com/office/drawing/2014/main" id="{3CFC9D30-E0FE-11C0-3B02-A9A8A0BDD5D1}"/>
-                </a:ext>
-              </a:extLst>
-            </p:cNvPr>
-            <p:cNvCxnSpPr>
-              <a:cxnSpLocks/>
-            </p:cNvCxnSpPr>
-            <p:nvPr/>
-          </p:nvCxnSpPr>
-          <p:spPr>
-            <a:xfrm>
-              <a:off x="1654294" y="2956562"/>
-              <a:ext cx="5984463" cy="0"/>
-            </a:xfrm>
-            <a:prstGeom prst="straightConnector1">
-              <a:avLst/>
-            </a:prstGeom>
-            <a:ln>
-              <a:tailEnd type="triangle"/>
-            </a:ln>
-          </p:spPr>
-          <p:style>
-            <a:lnRef idx="3">
-              <a:schemeClr val="dk1"/>
-            </a:lnRef>
-            <a:fillRef idx="0">
-              <a:schemeClr val="dk1"/>
-            </a:fillRef>
-            <a:effectRef idx="2">
-              <a:schemeClr val="dk1"/>
-            </a:effectRef>
-            <a:fontRef idx="minor">
-              <a:schemeClr val="tx1"/>
-            </a:fontRef>
-          </p:style>
-        </p:cxnSp>
-        <p:sp>
-          <p:nvSpPr>
-            <p:cNvPr id="56" name="Oval 55">
-              <a:extLst>
-                <a:ext uri="{FF2B5EF4-FFF2-40B4-BE49-F238E27FC236}">
-                  <a16:creationId xmlns:a16="http://schemas.microsoft.com/office/drawing/2014/main" id="{EC7C7213-00BD-E417-D779-FD3FC9DB913B}"/>
-                </a:ext>
-              </a:extLst>
-            </p:cNvPr>
-            <p:cNvSpPr/>
-            <p:nvPr/>
-          </p:nvSpPr>
-          <p:spPr>
-            <a:xfrm>
-              <a:off x="2471339" y="2795458"/>
-              <a:ext cx="323160" cy="322207"/>
-            </a:xfrm>
-            <a:prstGeom prst="ellipse">
-              <a:avLst/>
-            </a:prstGeom>
-          </p:spPr>
-          <p:style>
-            <a:lnRef idx="2">
-              <a:schemeClr val="dk1"/>
-            </a:lnRef>
-            <a:fillRef idx="1">
-              <a:schemeClr val="lt1"/>
-            </a:fillRef>
-            <a:effectRef idx="0">
-              <a:schemeClr val="dk1"/>
-            </a:effectRef>
-            <a:fontRef idx="minor">
-              <a:schemeClr val="dk1"/>
-            </a:fontRef>
-          </p:style>
-          <p:txBody>
-            <a:bodyPr rtlCol="0" anchor="ctr"/>
-            <a:lstStyle/>
-            <a:p>
-              <a:pPr algn="ctr"/>
-              <a:r>
-                <a:rPr lang="nl-NL" noProof="0" dirty="0"/>
-                <a:t>C</a:t>
-              </a:r>
-            </a:p>
-          </p:txBody>
-        </p:sp>
-        <p:sp>
-          <p:nvSpPr>
-            <p:cNvPr id="57" name="Oval 56">
-              <a:extLst>
-                <a:ext uri="{FF2B5EF4-FFF2-40B4-BE49-F238E27FC236}">
-                  <a16:creationId xmlns:a16="http://schemas.microsoft.com/office/drawing/2014/main" id="{0C4AD14D-93F8-49D2-FE07-7A3664F1AB5A}"/>
-                </a:ext>
-              </a:extLst>
-            </p:cNvPr>
-            <p:cNvSpPr/>
-            <p:nvPr/>
-          </p:nvSpPr>
-          <p:spPr>
-            <a:xfrm>
-              <a:off x="4484945" y="2795457"/>
-              <a:ext cx="323160" cy="322207"/>
-            </a:xfrm>
-            <a:prstGeom prst="ellipse">
-              <a:avLst/>
-            </a:prstGeom>
-            <a:solidFill>
-              <a:schemeClr val="accent6">
-                <a:lumMod val="40000"/>
-                <a:lumOff val="60000"/>
-              </a:schemeClr>
-            </a:solidFill>
-          </p:spPr>
-          <p:style>
-            <a:lnRef idx="2">
-              <a:schemeClr val="dk1"/>
-            </a:lnRef>
-            <a:fillRef idx="1">
-              <a:schemeClr val="lt1"/>
-            </a:fillRef>
-            <a:effectRef idx="0">
-              <a:schemeClr val="dk1"/>
-            </a:effectRef>
-            <a:fontRef idx="minor">
-              <a:schemeClr val="dk1"/>
-            </a:fontRef>
-          </p:style>
-          <p:txBody>
-            <a:bodyPr rtlCol="0" anchor="ctr"/>
-            <a:lstStyle/>
-            <a:p>
-              <a:pPr algn="ctr"/>
-              <a:r>
-                <a:rPr lang="nl-NL" noProof="0" dirty="0"/>
-                <a:t>C</a:t>
-              </a:r>
-            </a:p>
-          </p:txBody>
-        </p:sp>
-      </p:grpSp>
-      <p:sp>
-        <p:nvSpPr>
-          <p:cNvPr id="8" name="TextBox 7">
-            <a:extLst>
-              <a:ext uri="{FF2B5EF4-FFF2-40B4-BE49-F238E27FC236}">
-                <a16:creationId xmlns:a16="http://schemas.microsoft.com/office/drawing/2014/main" id="{EE1212B5-3EDE-43C8-C948-B4D7F263F6C8}"/>
-              </a:ext>
-            </a:extLst>
-          </p:cNvPr>
-          <p:cNvSpPr txBox="1"/>
-          <p:nvPr/>
-        </p:nvSpPr>
-        <p:spPr>
-          <a:xfrm>
-            <a:off x="2611984" y="2262344"/>
-            <a:ext cx="2426677" cy="400110"/>
-          </a:xfrm>
-          <a:prstGeom prst="rect">
-            <a:avLst/>
-          </a:prstGeom>
-          <a:noFill/>
-        </p:spPr>
-        <p:txBody>
-          <a:bodyPr wrap="square" rtlCol="0">
-            <a:spAutoFit/>
-          </a:bodyPr>
-          <a:lstStyle/>
-          <a:p>
-            <a:pPr algn="r"/>
-            <a:r>
-              <a:rPr lang="nl-NL" sz="2000" noProof="0" dirty="0"/>
-              <a:t>.git/refs/</a:t>
-            </a:r>
-            <a:r>
-              <a:rPr lang="nl-NL" sz="2000" noProof="0" dirty="0" err="1"/>
-              <a:t>heads</a:t>
-            </a:r>
-            <a:r>
-              <a:rPr lang="nl-NL" sz="2000" noProof="0" dirty="0"/>
-              <a:t>/</a:t>
-            </a:r>
-            <a:r>
-              <a:rPr lang="nl-NL" sz="2000" noProof="0" dirty="0" err="1"/>
-              <a:t>main</a:t>
-            </a:r>
-            <a:endParaRPr lang="nl-NL" sz="2000" noProof="0" dirty="0"/>
-          </a:p>
-        </p:txBody>
-      </p:sp>
-      <p:cxnSp>
-        <p:nvCxnSpPr>
-          <p:cNvPr id="9" name="Straight Arrow Connector 8">
-            <a:extLst>
-              <a:ext uri="{FF2B5EF4-FFF2-40B4-BE49-F238E27FC236}">
-                <a16:creationId xmlns:a16="http://schemas.microsoft.com/office/drawing/2014/main" id="{58CF1292-8334-3012-5170-FC75D5A11F6C}"/>
-              </a:ext>
-            </a:extLst>
-          </p:cNvPr>
-          <p:cNvCxnSpPr>
-            <a:cxnSpLocks/>
-          </p:cNvCxnSpPr>
-          <p:nvPr/>
-        </p:nvCxnSpPr>
-        <p:spPr>
-          <a:xfrm>
-            <a:off x="3832357" y="2662454"/>
-            <a:ext cx="0" cy="581253"/>
-          </a:xfrm>
-          <a:prstGeom prst="straightConnector1">
-            <a:avLst/>
-          </a:prstGeom>
-          <a:ln>
-            <a:tailEnd type="triangle"/>
-          </a:ln>
-        </p:spPr>
-        <p:style>
-          <a:lnRef idx="2">
-            <a:schemeClr val="dk1"/>
-          </a:lnRef>
-          <a:fillRef idx="0">
-            <a:schemeClr val="dk1"/>
-          </a:fillRef>
-          <a:effectRef idx="1">
-            <a:schemeClr val="dk1"/>
-          </a:effectRef>
-          <a:fontRef idx="minor">
-            <a:schemeClr val="tx1"/>
-          </a:fontRef>
-        </p:style>
-      </p:cxnSp>
-      <p:sp>
-        <p:nvSpPr>
-          <p:cNvPr id="10" name="Rectangle 9">
-            <a:extLst>
-              <a:ext uri="{FF2B5EF4-FFF2-40B4-BE49-F238E27FC236}">
-                <a16:creationId xmlns:a16="http://schemas.microsoft.com/office/drawing/2014/main" id="{2AAAF785-8D72-2035-335A-FBF916EC9E24}"/>
-              </a:ext>
-            </a:extLst>
-          </p:cNvPr>
-          <p:cNvSpPr/>
-          <p:nvPr/>
-        </p:nvSpPr>
-        <p:spPr>
-          <a:xfrm>
-            <a:off x="3892145" y="986750"/>
-            <a:ext cx="1793630" cy="538349"/>
-          </a:xfrm>
-          <a:prstGeom prst="rect">
-            <a:avLst/>
-          </a:prstGeom>
-          <a:ln>
-            <a:solidFill>
-              <a:schemeClr val="bg1"/>
-            </a:solidFill>
-          </a:ln>
-        </p:spPr>
-        <p:style>
-          <a:lnRef idx="2">
-            <a:schemeClr val="dk1"/>
-          </a:lnRef>
-          <a:fillRef idx="1">
-            <a:schemeClr val="lt1"/>
-          </a:fillRef>
-          <a:effectRef idx="0">
-            <a:schemeClr val="dk1"/>
-          </a:effectRef>
-          <a:fontRef idx="minor">
-            <a:schemeClr val="dk1"/>
-          </a:fontRef>
-        </p:style>
-        <p:txBody>
-          <a:bodyPr rtlCol="0" anchor="ctr"/>
-          <a:lstStyle/>
-          <a:p>
-            <a:pPr algn="ctr"/>
-            <a:r>
-              <a:rPr lang="nl-NL" noProof="0" dirty="0"/>
-              <a:t>.git/HEAD</a:t>
-            </a:r>
-          </a:p>
-        </p:txBody>
-      </p:sp>
-      <p:cxnSp>
-        <p:nvCxnSpPr>
-          <p:cNvPr id="11" name="Straight Arrow Connector 10">
-            <a:extLst>
-              <a:ext uri="{FF2B5EF4-FFF2-40B4-BE49-F238E27FC236}">
-                <a16:creationId xmlns:a16="http://schemas.microsoft.com/office/drawing/2014/main" id="{933FD7B4-BDAB-9AE6-7FCE-6B7CFC042D81}"/>
-              </a:ext>
-            </a:extLst>
-          </p:cNvPr>
-          <p:cNvCxnSpPr>
-            <a:cxnSpLocks/>
-            <a:stCxn id="10" idx="2"/>
-            <a:endCxn id="8" idx="0"/>
-          </p:cNvCxnSpPr>
-          <p:nvPr/>
-        </p:nvCxnSpPr>
-        <p:spPr>
-          <a:xfrm flipH="1">
-            <a:off x="3825323" y="1525099"/>
-            <a:ext cx="963637" cy="737245"/>
-          </a:xfrm>
-          <a:prstGeom prst="straightConnector1">
-            <a:avLst/>
-          </a:prstGeom>
-          <a:ln>
-            <a:tailEnd type="triangle"/>
-          </a:ln>
-        </p:spPr>
-        <p:style>
-          <a:lnRef idx="2">
-            <a:schemeClr val="dk1"/>
-          </a:lnRef>
-          <a:fillRef idx="0">
-            <a:schemeClr val="dk1"/>
-          </a:fillRef>
-          <a:effectRef idx="1">
-            <a:schemeClr val="dk1"/>
-          </a:effectRef>
-          <a:fontRef idx="minor">
-            <a:schemeClr val="tx1"/>
-          </a:fontRef>
-        </p:style>
-      </p:cxnSp>
-      <p:sp>
-        <p:nvSpPr>
-          <p:cNvPr id="3" name="Rectangle 2">
-            <a:extLst>
-              <a:ext uri="{FF2B5EF4-FFF2-40B4-BE49-F238E27FC236}">
-                <a16:creationId xmlns:a16="http://schemas.microsoft.com/office/drawing/2014/main" id="{3620CE6D-4636-CD14-6A5D-11DA74948FA9}"/>
-              </a:ext>
-            </a:extLst>
-          </p:cNvPr>
-          <p:cNvSpPr/>
-          <p:nvPr/>
-        </p:nvSpPr>
-        <p:spPr>
-          <a:xfrm>
-            <a:off x="5866228" y="738936"/>
-            <a:ext cx="2873492" cy="1033976"/>
-          </a:xfrm>
-          <a:prstGeom prst="rect">
-            <a:avLst/>
-          </a:prstGeom>
-          <a:solidFill>
-            <a:schemeClr val="accent4">
-              <a:lumMod val="20000"/>
-              <a:lumOff val="80000"/>
-            </a:schemeClr>
-          </a:solidFill>
-          <a:ln>
-            <a:solidFill>
-              <a:schemeClr val="accent4">
-                <a:lumMod val="60000"/>
-                <a:lumOff val="40000"/>
-              </a:schemeClr>
-            </a:solidFill>
-          </a:ln>
-        </p:spPr>
-        <p:style>
-          <a:lnRef idx="2">
-            <a:schemeClr val="accent1">
-              <a:shade val="15000"/>
-            </a:schemeClr>
-          </a:lnRef>
-          <a:fillRef idx="1">
-            <a:schemeClr val="accent1"/>
-          </a:fillRef>
-          <a:effectRef idx="0">
-            <a:schemeClr val="accent1"/>
-          </a:effectRef>
-          <a:fontRef idx="minor">
-            <a:schemeClr val="lt1"/>
-          </a:fontRef>
-        </p:style>
-        <p:txBody>
-          <a:bodyPr rtlCol="0" anchor="ctr"/>
-          <a:lstStyle/>
-          <a:p>
-            <a:pPr algn="ctr"/>
-            <a:r>
-              <a:rPr lang="nl-NL" noProof="0" dirty="0">
-                <a:solidFill>
-                  <a:sysClr val="windowText" lastClr="000000"/>
-                </a:solidFill>
-                <a:latin typeface="Courier New" panose="02070309020205020404" pitchFamily="49" charset="0"/>
-                <a:cs typeface="Courier New" panose="02070309020205020404" pitchFamily="49" charset="0"/>
-              </a:rPr>
-              <a:t>.git/HEAD</a:t>
-            </a:r>
-            <a:r>
-              <a:rPr lang="nl-NL" noProof="0" dirty="0">
-                <a:solidFill>
-                  <a:sysClr val="windowText" lastClr="000000"/>
-                </a:solidFill>
-              </a:rPr>
-              <a:t> geeft aan dat we op </a:t>
-            </a:r>
-            <a:r>
-              <a:rPr lang="nl-NL" noProof="0" dirty="0" err="1">
-                <a:solidFill>
-                  <a:sysClr val="windowText" lastClr="000000"/>
-                </a:solidFill>
-                <a:latin typeface="Courier New" panose="02070309020205020404" pitchFamily="49" charset="0"/>
-                <a:cs typeface="Courier New" panose="02070309020205020404" pitchFamily="49" charset="0"/>
-              </a:rPr>
-              <a:t>main</a:t>
-            </a:r>
-            <a:r>
-              <a:rPr lang="nl-NL" noProof="0" dirty="0">
-                <a:solidFill>
-                  <a:sysClr val="windowText" lastClr="000000"/>
-                </a:solidFill>
-              </a:rPr>
-              <a:t> werken.</a:t>
-            </a:r>
-          </a:p>
-        </p:txBody>
-      </p:sp>
-      <p:cxnSp>
-        <p:nvCxnSpPr>
-          <p:cNvPr id="6" name="Connector: Curved 5">
-            <a:extLst>
-              <a:ext uri="{FF2B5EF4-FFF2-40B4-BE49-F238E27FC236}">
-                <a16:creationId xmlns:a16="http://schemas.microsoft.com/office/drawing/2014/main" id="{0AB7E9EA-3F04-1E95-C10D-A00C93F2177A}"/>
+          <p:cNvPr id="3" name="Connector: Curved 2">
+            <a:extLst>
+              <a:ext uri="{FF2B5EF4-FFF2-40B4-BE49-F238E27FC236}">
+                <a16:creationId xmlns:a16="http://schemas.microsoft.com/office/drawing/2014/main" id="{DA5D32D2-9002-4252-F245-5D597EC8003A}"/>
               </a:ext>
             </a:extLst>
           </p:cNvPr>
@@ -24955,7 +24692,7 @@
     </p:spTree>
     <p:extLst>
       <p:ext uri="{BB962C8B-B14F-4D97-AF65-F5344CB8AC3E}">
-        <p14:creationId xmlns:p14="http://schemas.microsoft.com/office/powerpoint/2010/main" val="3043967204"/>
+        <p14:creationId xmlns:p14="http://schemas.microsoft.com/office/powerpoint/2010/main" val="458030483"/>
       </p:ext>
     </p:extLst>
   </p:cSld>
@@ -24965,7 +24702,7 @@
 </p:sld>
 </file>
 
-<file path=ppt/slides/slide37.xml><?xml version="1.0" encoding="utf-8"?>
+<file path=ppt/slides/slide36.xml><?xml version="1.0" encoding="utf-8"?>
 <p:sld xmlns:a="http://schemas.openxmlformats.org/drawingml/2006/main" xmlns:r="http://schemas.openxmlformats.org/officeDocument/2006/relationships" xmlns:p="http://schemas.openxmlformats.org/presentationml/2006/main">
   <p:cSld>
     <p:spTree>
@@ -25439,101 +25176,6 @@
       </p:cxnSp>
       <p:cxnSp>
         <p:nvCxnSpPr>
-          <p:cNvPr id="17" name="Straight Arrow Connector 16">
-            <a:extLst>
-              <a:ext uri="{FF2B5EF4-FFF2-40B4-BE49-F238E27FC236}">
-                <a16:creationId xmlns:a16="http://schemas.microsoft.com/office/drawing/2014/main" id="{316C01DB-C7F2-5D89-23B9-8F4B8CDADCE8}"/>
-              </a:ext>
-            </a:extLst>
-          </p:cNvPr>
-          <p:cNvCxnSpPr>
-            <a:cxnSpLocks/>
-            <a:stCxn id="7" idx="2"/>
-            <a:endCxn id="13" idx="0"/>
-          </p:cNvCxnSpPr>
-          <p:nvPr/>
-        </p:nvCxnSpPr>
-        <p:spPr>
-          <a:xfrm>
-            <a:off x="4788960" y="1525099"/>
-            <a:ext cx="1055077" cy="737245"/>
-          </a:xfrm>
-          <a:prstGeom prst="straightConnector1">
-            <a:avLst/>
-          </a:prstGeom>
-          <a:ln>
-            <a:tailEnd type="triangle"/>
-          </a:ln>
-        </p:spPr>
-        <p:style>
-          <a:lnRef idx="2">
-            <a:schemeClr val="dk1"/>
-          </a:lnRef>
-          <a:fillRef idx="0">
-            <a:schemeClr val="dk1"/>
-          </a:fillRef>
-          <a:effectRef idx="1">
-            <a:schemeClr val="dk1"/>
-          </a:effectRef>
-          <a:fontRef idx="minor">
-            <a:schemeClr val="tx1"/>
-          </a:fontRef>
-        </p:style>
-      </p:cxnSp>
-      <p:sp>
-        <p:nvSpPr>
-          <p:cNvPr id="7" name="Rectangle 6">
-            <a:extLst>
-              <a:ext uri="{FF2B5EF4-FFF2-40B4-BE49-F238E27FC236}">
-                <a16:creationId xmlns:a16="http://schemas.microsoft.com/office/drawing/2014/main" id="{FFCE56ED-F39D-2C3C-4ECA-0D9585DB3A30}"/>
-              </a:ext>
-            </a:extLst>
-          </p:cNvPr>
-          <p:cNvSpPr/>
-          <p:nvPr/>
-        </p:nvSpPr>
-        <p:spPr>
-          <a:xfrm>
-            <a:off x="3892145" y="986750"/>
-            <a:ext cx="1793630" cy="538349"/>
-          </a:xfrm>
-          <a:prstGeom prst="rect">
-            <a:avLst/>
-          </a:prstGeom>
-          <a:ln>
-            <a:solidFill>
-              <a:schemeClr val="bg1"/>
-            </a:solidFill>
-          </a:ln>
-        </p:spPr>
-        <p:style>
-          <a:lnRef idx="2">
-            <a:schemeClr val="dk1"/>
-          </a:lnRef>
-          <a:fillRef idx="1">
-            <a:schemeClr val="lt1"/>
-          </a:fillRef>
-          <a:effectRef idx="0">
-            <a:schemeClr val="dk1"/>
-          </a:effectRef>
-          <a:fontRef idx="minor">
-            <a:schemeClr val="dk1"/>
-          </a:fontRef>
-        </p:style>
-        <p:txBody>
-          <a:bodyPr rtlCol="0" anchor="ctr"/>
-          <a:lstStyle/>
-          <a:p>
-            <a:pPr algn="ctr"/>
-            <a:r>
-              <a:rPr lang="nl-NL" noProof="0" dirty="0"/>
-              <a:t>.git/HEAD</a:t>
-            </a:r>
-          </a:p>
-        </p:txBody>
-      </p:sp>
-      <p:cxnSp>
-        <p:nvCxnSpPr>
           <p:cNvPr id="3" name="Connector: Curved 2">
             <a:extLst>
               <a:ext uri="{FF2B5EF4-FFF2-40B4-BE49-F238E27FC236}">
@@ -25622,6 +25264,688 @@
     <p:extLst>
       <p:ext uri="{BB962C8B-B14F-4D97-AF65-F5344CB8AC3E}">
         <p14:creationId xmlns:p14="http://schemas.microsoft.com/office/powerpoint/2010/main" val="2136345676"/>
+      </p:ext>
+    </p:extLst>
+  </p:cSld>
+  <p:clrMapOvr>
+    <a:masterClrMapping/>
+  </p:clrMapOvr>
+</p:sld>
+</file>
+
+<file path=ppt/slides/slide37.xml><?xml version="1.0" encoding="utf-8"?>
+<p:sld xmlns:a="http://schemas.openxmlformats.org/drawingml/2006/main" xmlns:r="http://schemas.openxmlformats.org/officeDocument/2006/relationships" xmlns:p="http://schemas.openxmlformats.org/presentationml/2006/main">
+  <p:cSld>
+    <p:spTree>
+      <p:nvGrpSpPr>
+        <p:cNvPr id="1" name="">
+          <a:extLst>
+            <a:ext uri="{FF2B5EF4-FFF2-40B4-BE49-F238E27FC236}">
+              <a16:creationId xmlns:a16="http://schemas.microsoft.com/office/drawing/2014/main" id="{39A65AA0-396A-800B-5F73-C222DC679CA6}"/>
+            </a:ext>
+          </a:extLst>
+        </p:cNvPr>
+        <p:cNvGrpSpPr/>
+        <p:nvPr/>
+      </p:nvGrpSpPr>
+      <p:grpSpPr>
+        <a:xfrm>
+          <a:off x="0" y="0"/>
+          <a:ext cx="0" cy="0"/>
+          <a:chOff x="0" y="0"/>
+          <a:chExt cx="0" cy="0"/>
+        </a:xfrm>
+      </p:grpSpPr>
+      <p:sp>
+        <p:nvSpPr>
+          <p:cNvPr id="2" name="Title 1">
+            <a:extLst>
+              <a:ext uri="{FF2B5EF4-FFF2-40B4-BE49-F238E27FC236}">
+                <a16:creationId xmlns:a16="http://schemas.microsoft.com/office/drawing/2014/main" id="{D0B04163-FE04-715F-5470-3A5BD7866CA4}"/>
+              </a:ext>
+            </a:extLst>
+          </p:cNvPr>
+          <p:cNvSpPr>
+            <a:spLocks noGrp="1"/>
+          </p:cNvSpPr>
+          <p:nvPr>
+            <p:ph type="title"/>
+          </p:nvPr>
+        </p:nvSpPr>
+        <p:spPr>
+          <a:xfrm>
+            <a:off x="838200" y="365126"/>
+            <a:ext cx="10515600" cy="718608"/>
+          </a:xfrm>
+        </p:spPr>
+        <p:txBody>
+          <a:bodyPr>
+            <a:normAutofit/>
+          </a:bodyPr>
+          <a:lstStyle/>
+          <a:p>
+            <a:r>
+              <a:rPr lang="nl-NL" sz="3600" noProof="0" dirty="0"/>
+              <a:t>Branches</a:t>
+            </a:r>
+          </a:p>
+        </p:txBody>
+      </p:sp>
+      <p:grpSp>
+        <p:nvGrpSpPr>
+          <p:cNvPr id="4" name="Group 3">
+            <a:extLst>
+              <a:ext uri="{FF2B5EF4-FFF2-40B4-BE49-F238E27FC236}">
+                <a16:creationId xmlns:a16="http://schemas.microsoft.com/office/drawing/2014/main" id="{C5A1758B-C194-38DA-8F4C-1615054DF267}"/>
+              </a:ext>
+            </a:extLst>
+          </p:cNvPr>
+          <p:cNvGrpSpPr/>
+          <p:nvPr/>
+        </p:nvGrpSpPr>
+        <p:grpSpPr>
+          <a:xfrm>
+            <a:off x="838200" y="3238594"/>
+            <a:ext cx="5984463" cy="327320"/>
+            <a:chOff x="1654294" y="2795457"/>
+            <a:chExt cx="5984463" cy="327320"/>
+          </a:xfrm>
+        </p:grpSpPr>
+        <p:cxnSp>
+          <p:nvCxnSpPr>
+            <p:cNvPr id="5" name="Straight Arrow Connector 4">
+              <a:extLst>
+                <a:ext uri="{FF2B5EF4-FFF2-40B4-BE49-F238E27FC236}">
+                  <a16:creationId xmlns:a16="http://schemas.microsoft.com/office/drawing/2014/main" id="{96D72D96-5593-55D9-F04E-9B51291E53FE}"/>
+                </a:ext>
+              </a:extLst>
+            </p:cNvPr>
+            <p:cNvCxnSpPr>
+              <a:cxnSpLocks/>
+            </p:cNvCxnSpPr>
+            <p:nvPr/>
+          </p:nvCxnSpPr>
+          <p:spPr>
+            <a:xfrm>
+              <a:off x="1654294" y="2956562"/>
+              <a:ext cx="5984463" cy="0"/>
+            </a:xfrm>
+            <a:prstGeom prst="straightConnector1">
+              <a:avLst/>
+            </a:prstGeom>
+            <a:ln>
+              <a:tailEnd type="triangle"/>
+            </a:ln>
+          </p:spPr>
+          <p:style>
+            <a:lnRef idx="3">
+              <a:schemeClr val="dk1"/>
+            </a:lnRef>
+            <a:fillRef idx="0">
+              <a:schemeClr val="dk1"/>
+            </a:fillRef>
+            <a:effectRef idx="2">
+              <a:schemeClr val="dk1"/>
+            </a:effectRef>
+            <a:fontRef idx="minor">
+              <a:schemeClr val="tx1"/>
+            </a:fontRef>
+          </p:style>
+        </p:cxnSp>
+        <p:sp>
+          <p:nvSpPr>
+            <p:cNvPr id="56" name="Oval 55">
+              <a:extLst>
+                <a:ext uri="{FF2B5EF4-FFF2-40B4-BE49-F238E27FC236}">
+                  <a16:creationId xmlns:a16="http://schemas.microsoft.com/office/drawing/2014/main" id="{FF95DA78-A5E1-319D-8AA3-47DB12A1A7A3}"/>
+                </a:ext>
+              </a:extLst>
+            </p:cNvPr>
+            <p:cNvSpPr/>
+            <p:nvPr/>
+          </p:nvSpPr>
+          <p:spPr>
+            <a:xfrm>
+              <a:off x="2471339" y="2795458"/>
+              <a:ext cx="323160" cy="322207"/>
+            </a:xfrm>
+            <a:prstGeom prst="ellipse">
+              <a:avLst/>
+            </a:prstGeom>
+          </p:spPr>
+          <p:style>
+            <a:lnRef idx="2">
+              <a:schemeClr val="dk1"/>
+            </a:lnRef>
+            <a:fillRef idx="1">
+              <a:schemeClr val="lt1"/>
+            </a:fillRef>
+            <a:effectRef idx="0">
+              <a:schemeClr val="dk1"/>
+            </a:effectRef>
+            <a:fontRef idx="minor">
+              <a:schemeClr val="dk1"/>
+            </a:fontRef>
+          </p:style>
+          <p:txBody>
+            <a:bodyPr rtlCol="0" anchor="ctr"/>
+            <a:lstStyle/>
+            <a:p>
+              <a:pPr algn="ctr"/>
+              <a:r>
+                <a:rPr lang="nl-NL" noProof="0" dirty="0"/>
+                <a:t>C</a:t>
+              </a:r>
+            </a:p>
+          </p:txBody>
+        </p:sp>
+        <p:sp>
+          <p:nvSpPr>
+            <p:cNvPr id="57" name="Oval 56">
+              <a:extLst>
+                <a:ext uri="{FF2B5EF4-FFF2-40B4-BE49-F238E27FC236}">
+                  <a16:creationId xmlns:a16="http://schemas.microsoft.com/office/drawing/2014/main" id="{3BEC8197-22E3-0BC5-EBC9-B93EC2A9958C}"/>
+                </a:ext>
+              </a:extLst>
+            </p:cNvPr>
+            <p:cNvSpPr/>
+            <p:nvPr/>
+          </p:nvSpPr>
+          <p:spPr>
+            <a:xfrm>
+              <a:off x="4484945" y="2795457"/>
+              <a:ext cx="323160" cy="322207"/>
+            </a:xfrm>
+            <a:prstGeom prst="ellipse">
+              <a:avLst/>
+            </a:prstGeom>
+          </p:spPr>
+          <p:style>
+            <a:lnRef idx="2">
+              <a:schemeClr val="dk1"/>
+            </a:lnRef>
+            <a:fillRef idx="1">
+              <a:schemeClr val="lt1"/>
+            </a:fillRef>
+            <a:effectRef idx="0">
+              <a:schemeClr val="dk1"/>
+            </a:effectRef>
+            <a:fontRef idx="minor">
+              <a:schemeClr val="dk1"/>
+            </a:fontRef>
+          </p:style>
+          <p:txBody>
+            <a:bodyPr rtlCol="0" anchor="ctr"/>
+            <a:lstStyle/>
+            <a:p>
+              <a:pPr algn="ctr"/>
+              <a:r>
+                <a:rPr lang="nl-NL" noProof="0" dirty="0"/>
+                <a:t>C</a:t>
+              </a:r>
+            </a:p>
+          </p:txBody>
+        </p:sp>
+        <p:sp>
+          <p:nvSpPr>
+            <p:cNvPr id="58" name="Oval 57">
+              <a:extLst>
+                <a:ext uri="{FF2B5EF4-FFF2-40B4-BE49-F238E27FC236}">
+                  <a16:creationId xmlns:a16="http://schemas.microsoft.com/office/drawing/2014/main" id="{FBE0106D-8978-B318-D791-BB9FE952FD4E}"/>
+                </a:ext>
+              </a:extLst>
+            </p:cNvPr>
+            <p:cNvSpPr/>
+            <p:nvPr/>
+          </p:nvSpPr>
+          <p:spPr>
+            <a:xfrm>
+              <a:off x="6498551" y="2800570"/>
+              <a:ext cx="323160" cy="322207"/>
+            </a:xfrm>
+            <a:prstGeom prst="ellipse">
+              <a:avLst/>
+            </a:prstGeom>
+            <a:solidFill>
+              <a:schemeClr val="accent6">
+                <a:lumMod val="40000"/>
+                <a:lumOff val="60000"/>
+              </a:schemeClr>
+            </a:solidFill>
+          </p:spPr>
+          <p:style>
+            <a:lnRef idx="2">
+              <a:schemeClr val="dk1"/>
+            </a:lnRef>
+            <a:fillRef idx="1">
+              <a:schemeClr val="lt1"/>
+            </a:fillRef>
+            <a:effectRef idx="0">
+              <a:schemeClr val="dk1"/>
+            </a:effectRef>
+            <a:fontRef idx="minor">
+              <a:schemeClr val="dk1"/>
+            </a:fontRef>
+          </p:style>
+          <p:txBody>
+            <a:bodyPr rtlCol="0" anchor="ctr"/>
+            <a:lstStyle/>
+            <a:p>
+              <a:pPr algn="ctr"/>
+              <a:r>
+                <a:rPr lang="nl-NL" noProof="0" dirty="0"/>
+                <a:t>C</a:t>
+              </a:r>
+            </a:p>
+          </p:txBody>
+        </p:sp>
+      </p:grpSp>
+      <p:sp>
+        <p:nvSpPr>
+          <p:cNvPr id="13" name="TextBox 12">
+            <a:extLst>
+              <a:ext uri="{FF2B5EF4-FFF2-40B4-BE49-F238E27FC236}">
+                <a16:creationId xmlns:a16="http://schemas.microsoft.com/office/drawing/2014/main" id="{9C702EC0-D412-A054-FA51-EAB4A93DF840}"/>
+              </a:ext>
+            </a:extLst>
+          </p:cNvPr>
+          <p:cNvSpPr txBox="1"/>
+          <p:nvPr/>
+        </p:nvSpPr>
+        <p:spPr>
+          <a:xfrm>
+            <a:off x="4630698" y="2262344"/>
+            <a:ext cx="2426677" cy="400110"/>
+          </a:xfrm>
+          <a:prstGeom prst="rect">
+            <a:avLst/>
+          </a:prstGeom>
+          <a:noFill/>
+        </p:spPr>
+        <p:txBody>
+          <a:bodyPr wrap="square" rtlCol="0">
+            <a:spAutoFit/>
+          </a:bodyPr>
+          <a:lstStyle/>
+          <a:p>
+            <a:pPr algn="r"/>
+            <a:r>
+              <a:rPr lang="nl-NL" sz="2000" noProof="0" dirty="0"/>
+              <a:t>.git/refs/</a:t>
+            </a:r>
+            <a:r>
+              <a:rPr lang="nl-NL" sz="2000" noProof="0" dirty="0" err="1"/>
+              <a:t>heads</a:t>
+            </a:r>
+            <a:r>
+              <a:rPr lang="nl-NL" sz="2000" noProof="0" dirty="0"/>
+              <a:t>/</a:t>
+            </a:r>
+            <a:r>
+              <a:rPr lang="nl-NL" sz="2000" noProof="0" dirty="0" err="1"/>
+              <a:t>main</a:t>
+            </a:r>
+            <a:endParaRPr lang="nl-NL" sz="2000" noProof="0" dirty="0"/>
+          </a:p>
+        </p:txBody>
+      </p:sp>
+      <p:cxnSp>
+        <p:nvCxnSpPr>
+          <p:cNvPr id="6" name="Straight Arrow Connector 5">
+            <a:extLst>
+              <a:ext uri="{FF2B5EF4-FFF2-40B4-BE49-F238E27FC236}">
+                <a16:creationId xmlns:a16="http://schemas.microsoft.com/office/drawing/2014/main" id="{D4FCF294-5FCF-F5D1-DF22-C1C1BF2103B7}"/>
+              </a:ext>
+            </a:extLst>
+          </p:cNvPr>
+          <p:cNvCxnSpPr>
+            <a:stCxn id="13" idx="2"/>
+            <a:endCxn id="58" idx="0"/>
+          </p:cNvCxnSpPr>
+          <p:nvPr/>
+        </p:nvCxnSpPr>
+        <p:spPr>
+          <a:xfrm>
+            <a:off x="5844037" y="2662454"/>
+            <a:ext cx="0" cy="581253"/>
+          </a:xfrm>
+          <a:prstGeom prst="straightConnector1">
+            <a:avLst/>
+          </a:prstGeom>
+          <a:ln>
+            <a:tailEnd type="triangle"/>
+          </a:ln>
+        </p:spPr>
+        <p:style>
+          <a:lnRef idx="2">
+            <a:schemeClr val="dk1"/>
+          </a:lnRef>
+          <a:fillRef idx="0">
+            <a:schemeClr val="dk1"/>
+          </a:fillRef>
+          <a:effectRef idx="1">
+            <a:schemeClr val="dk1"/>
+          </a:effectRef>
+          <a:fontRef idx="minor">
+            <a:schemeClr val="tx1"/>
+          </a:fontRef>
+        </p:style>
+      </p:cxnSp>
+      <p:cxnSp>
+        <p:nvCxnSpPr>
+          <p:cNvPr id="3" name="Connector: Curved 2">
+            <a:extLst>
+              <a:ext uri="{FF2B5EF4-FFF2-40B4-BE49-F238E27FC236}">
+                <a16:creationId xmlns:a16="http://schemas.microsoft.com/office/drawing/2014/main" id="{99EDCC1E-57B2-14F6-C820-974052D00BB0}"/>
+              </a:ext>
+            </a:extLst>
+          </p:cNvPr>
+          <p:cNvCxnSpPr>
+            <a:cxnSpLocks/>
+          </p:cNvCxnSpPr>
+          <p:nvPr/>
+        </p:nvCxnSpPr>
+        <p:spPr>
+          <a:xfrm rot="5400000">
+            <a:off x="2825553" y="2634548"/>
+            <a:ext cx="1" cy="2013606"/>
+          </a:xfrm>
+          <a:prstGeom prst="curvedConnector3">
+            <a:avLst>
+              <a:gd name="adj1" fmla="val 22860100000"/>
+            </a:avLst>
+          </a:prstGeom>
+          <a:ln>
+            <a:tailEnd type="triangle"/>
+          </a:ln>
+        </p:spPr>
+        <p:style>
+          <a:lnRef idx="2">
+            <a:schemeClr val="dk1"/>
+          </a:lnRef>
+          <a:fillRef idx="0">
+            <a:schemeClr val="dk1"/>
+          </a:fillRef>
+          <a:effectRef idx="1">
+            <a:schemeClr val="dk1"/>
+          </a:effectRef>
+          <a:fontRef idx="minor">
+            <a:schemeClr val="tx1"/>
+          </a:fontRef>
+        </p:style>
+      </p:cxnSp>
+      <p:cxnSp>
+        <p:nvCxnSpPr>
+          <p:cNvPr id="8" name="Connector: Curved 7">
+            <a:extLst>
+              <a:ext uri="{FF2B5EF4-FFF2-40B4-BE49-F238E27FC236}">
+                <a16:creationId xmlns:a16="http://schemas.microsoft.com/office/drawing/2014/main" id="{BBE35586-E098-2092-CA38-9D719A9AE8DB}"/>
+              </a:ext>
+            </a:extLst>
+          </p:cNvPr>
+          <p:cNvCxnSpPr>
+            <a:cxnSpLocks/>
+          </p:cNvCxnSpPr>
+          <p:nvPr/>
+        </p:nvCxnSpPr>
+        <p:spPr>
+          <a:xfrm rot="5400000">
+            <a:off x="4837233" y="2628149"/>
+            <a:ext cx="1" cy="2013606"/>
+          </a:xfrm>
+          <a:prstGeom prst="curvedConnector3">
+            <a:avLst>
+              <a:gd name="adj1" fmla="val 22860100000"/>
+            </a:avLst>
+          </a:prstGeom>
+          <a:ln>
+            <a:tailEnd type="triangle"/>
+          </a:ln>
+        </p:spPr>
+        <p:style>
+          <a:lnRef idx="2">
+            <a:schemeClr val="dk1"/>
+          </a:lnRef>
+          <a:fillRef idx="0">
+            <a:schemeClr val="dk1"/>
+          </a:fillRef>
+          <a:effectRef idx="1">
+            <a:schemeClr val="dk1"/>
+          </a:effectRef>
+          <a:fontRef idx="minor">
+            <a:schemeClr val="tx1"/>
+          </a:fontRef>
+        </p:style>
+      </p:cxnSp>
+      <p:sp>
+        <p:nvSpPr>
+          <p:cNvPr id="7" name="Rectangle 6">
+            <a:extLst>
+              <a:ext uri="{FF2B5EF4-FFF2-40B4-BE49-F238E27FC236}">
+                <a16:creationId xmlns:a16="http://schemas.microsoft.com/office/drawing/2014/main" id="{8E25D6C0-850C-D70A-49F9-4FD395EEDE30}"/>
+              </a:ext>
+            </a:extLst>
+          </p:cNvPr>
+          <p:cNvSpPr/>
+          <p:nvPr/>
+        </p:nvSpPr>
+        <p:spPr>
+          <a:xfrm>
+            <a:off x="4947221" y="986750"/>
+            <a:ext cx="1793630" cy="538349"/>
+          </a:xfrm>
+          <a:prstGeom prst="rect">
+            <a:avLst/>
+          </a:prstGeom>
+          <a:ln>
+            <a:solidFill>
+              <a:schemeClr val="bg1"/>
+            </a:solidFill>
+          </a:ln>
+        </p:spPr>
+        <p:style>
+          <a:lnRef idx="2">
+            <a:schemeClr val="dk1"/>
+          </a:lnRef>
+          <a:fillRef idx="1">
+            <a:schemeClr val="lt1"/>
+          </a:fillRef>
+          <a:effectRef idx="0">
+            <a:schemeClr val="dk1"/>
+          </a:effectRef>
+          <a:fontRef idx="minor">
+            <a:schemeClr val="dk1"/>
+          </a:fontRef>
+        </p:style>
+        <p:txBody>
+          <a:bodyPr rtlCol="0" anchor="ctr"/>
+          <a:lstStyle/>
+          <a:p>
+            <a:pPr algn="ctr"/>
+            <a:r>
+              <a:rPr lang="nl-NL" noProof="0" dirty="0"/>
+              <a:t>.git/HEAD</a:t>
+            </a:r>
+          </a:p>
+        </p:txBody>
+      </p:sp>
+      <p:sp>
+        <p:nvSpPr>
+          <p:cNvPr id="9" name="Rectangle 8">
+            <a:extLst>
+              <a:ext uri="{FF2B5EF4-FFF2-40B4-BE49-F238E27FC236}">
+                <a16:creationId xmlns:a16="http://schemas.microsoft.com/office/drawing/2014/main" id="{8C97C22B-BA56-927C-6005-237C74EC8149}"/>
+              </a:ext>
+            </a:extLst>
+          </p:cNvPr>
+          <p:cNvSpPr/>
+          <p:nvPr/>
+        </p:nvSpPr>
+        <p:spPr>
+          <a:xfrm>
+            <a:off x="8023949" y="738936"/>
+            <a:ext cx="2873492" cy="1033976"/>
+          </a:xfrm>
+          <a:prstGeom prst="rect">
+            <a:avLst/>
+          </a:prstGeom>
+          <a:solidFill>
+            <a:schemeClr val="accent4">
+              <a:lumMod val="20000"/>
+              <a:lumOff val="80000"/>
+            </a:schemeClr>
+          </a:solidFill>
+          <a:ln>
+            <a:solidFill>
+              <a:schemeClr val="accent4">
+                <a:lumMod val="60000"/>
+                <a:lumOff val="40000"/>
+              </a:schemeClr>
+            </a:solidFill>
+          </a:ln>
+        </p:spPr>
+        <p:style>
+          <a:lnRef idx="2">
+            <a:schemeClr val="accent1">
+              <a:shade val="15000"/>
+            </a:schemeClr>
+          </a:lnRef>
+          <a:fillRef idx="1">
+            <a:schemeClr val="accent1"/>
+          </a:fillRef>
+          <a:effectRef idx="0">
+            <a:schemeClr val="accent1"/>
+          </a:effectRef>
+          <a:fontRef idx="minor">
+            <a:schemeClr val="lt1"/>
+          </a:fontRef>
+        </p:style>
+        <p:txBody>
+          <a:bodyPr rtlCol="0" anchor="ctr"/>
+          <a:lstStyle/>
+          <a:p>
+            <a:pPr algn="ctr"/>
+            <a:r>
+              <a:rPr lang="nl-NL" noProof="0" dirty="0">
+                <a:solidFill>
+                  <a:sysClr val="windowText" lastClr="000000"/>
+                </a:solidFill>
+                <a:latin typeface="Courier New" panose="02070309020205020404" pitchFamily="49" charset="0"/>
+                <a:cs typeface="Courier New" panose="02070309020205020404" pitchFamily="49" charset="0"/>
+              </a:rPr>
+              <a:t>.git/HEAD</a:t>
+            </a:r>
+            <a:r>
+              <a:rPr lang="nl-NL" noProof="0" dirty="0">
+                <a:solidFill>
+                  <a:sysClr val="windowText" lastClr="000000"/>
+                </a:solidFill>
+              </a:rPr>
+              <a:t> geeft aan dat we op </a:t>
+            </a:r>
+            <a:r>
+              <a:rPr lang="nl-NL" noProof="0" dirty="0" err="1">
+                <a:solidFill>
+                  <a:sysClr val="windowText" lastClr="000000"/>
+                </a:solidFill>
+                <a:latin typeface="Courier New" panose="02070309020205020404" pitchFamily="49" charset="0"/>
+                <a:cs typeface="Courier New" panose="02070309020205020404" pitchFamily="49" charset="0"/>
+              </a:rPr>
+              <a:t>main</a:t>
+            </a:r>
+            <a:r>
+              <a:rPr lang="nl-NL" noProof="0" dirty="0">
+                <a:solidFill>
+                  <a:sysClr val="windowText" lastClr="000000"/>
+                </a:solidFill>
+              </a:rPr>
+              <a:t> werken.</a:t>
+            </a:r>
+          </a:p>
+        </p:txBody>
+      </p:sp>
+      <p:cxnSp>
+        <p:nvCxnSpPr>
+          <p:cNvPr id="11" name="Straight Arrow Connector 10">
+            <a:extLst>
+              <a:ext uri="{FF2B5EF4-FFF2-40B4-BE49-F238E27FC236}">
+                <a16:creationId xmlns:a16="http://schemas.microsoft.com/office/drawing/2014/main" id="{763107A2-B82A-69F7-CB98-9493EFBAB831}"/>
+              </a:ext>
+            </a:extLst>
+          </p:cNvPr>
+          <p:cNvCxnSpPr>
+            <a:stCxn id="7" idx="2"/>
+            <a:endCxn id="13" idx="0"/>
+          </p:cNvCxnSpPr>
+          <p:nvPr/>
+        </p:nvCxnSpPr>
+        <p:spPr>
+          <a:xfrm>
+            <a:off x="5844036" y="1525099"/>
+            <a:ext cx="1" cy="737245"/>
+          </a:xfrm>
+          <a:prstGeom prst="straightConnector1">
+            <a:avLst/>
+          </a:prstGeom>
+          <a:ln>
+            <a:tailEnd type="triangle"/>
+          </a:ln>
+        </p:spPr>
+        <p:style>
+          <a:lnRef idx="3">
+            <a:schemeClr val="dk1"/>
+          </a:lnRef>
+          <a:fillRef idx="0">
+            <a:schemeClr val="dk1"/>
+          </a:fillRef>
+          <a:effectRef idx="2">
+            <a:schemeClr val="dk1"/>
+          </a:effectRef>
+          <a:fontRef idx="minor">
+            <a:schemeClr val="tx1"/>
+          </a:fontRef>
+        </p:style>
+      </p:cxnSp>
+      <p:sp>
+        <p:nvSpPr>
+          <p:cNvPr id="15" name="TextBox 14">
+            <a:extLst>
+              <a:ext uri="{FF2B5EF4-FFF2-40B4-BE49-F238E27FC236}">
+                <a16:creationId xmlns:a16="http://schemas.microsoft.com/office/drawing/2014/main" id="{DF36D6F0-D1CE-B140-6E81-DA4555A4FED3}"/>
+              </a:ext>
+            </a:extLst>
+          </p:cNvPr>
+          <p:cNvSpPr txBox="1"/>
+          <p:nvPr/>
+        </p:nvSpPr>
+        <p:spPr>
+          <a:xfrm>
+            <a:off x="9619967" y="6471982"/>
+            <a:ext cx="2499246" cy="307777"/>
+          </a:xfrm>
+          <a:prstGeom prst="rect">
+            <a:avLst/>
+          </a:prstGeom>
+          <a:noFill/>
+        </p:spPr>
+        <p:txBody>
+          <a:bodyPr wrap="square">
+            <a:spAutoFit/>
+          </a:bodyPr>
+          <a:lstStyle/>
+          <a:p>
+            <a:pPr algn="r"/>
+            <a:r>
+              <a:rPr lang="en-US" sz="1400" dirty="0"/>
+              <a:t>D: HEAD and refs.</a:t>
+            </a:r>
+          </a:p>
+        </p:txBody>
+      </p:sp>
+    </p:spTree>
+    <p:extLst>
+      <p:ext uri="{BB962C8B-B14F-4D97-AF65-F5344CB8AC3E}">
+        <p14:creationId xmlns:p14="http://schemas.microsoft.com/office/powerpoint/2010/main" val="3390769583"/>
       </p:ext>
     </p:extLst>
   </p:cSld>
@@ -26247,63 +26571,21 @@
           </a:p>
         </p:txBody>
       </p:sp>
-      <p:cxnSp>
-        <p:nvCxnSpPr>
-          <p:cNvPr id="10" name="Straight Arrow Connector 9">
-            <a:extLst>
-              <a:ext uri="{FF2B5EF4-FFF2-40B4-BE49-F238E27FC236}">
-                <a16:creationId xmlns:a16="http://schemas.microsoft.com/office/drawing/2014/main" id="{DAE774A3-A228-72F4-D928-5FDECE7ED41D}"/>
-              </a:ext>
-            </a:extLst>
-          </p:cNvPr>
-          <p:cNvCxnSpPr>
-            <a:cxnSpLocks/>
-            <a:stCxn id="11" idx="2"/>
-          </p:cNvCxnSpPr>
+      <p:sp>
+        <p:nvSpPr>
+          <p:cNvPr id="14" name="Rectangle 13">
+            <a:extLst>
+              <a:ext uri="{FF2B5EF4-FFF2-40B4-BE49-F238E27FC236}">
+                <a16:creationId xmlns:a16="http://schemas.microsoft.com/office/drawing/2014/main" id="{8214520F-48AF-FA1B-0498-E25C211B1919}"/>
+              </a:ext>
+            </a:extLst>
+          </p:cNvPr>
+          <p:cNvSpPr/>
           <p:nvPr/>
-        </p:nvCxnSpPr>
+        </p:nvSpPr>
         <p:spPr>
           <a:xfrm>
-            <a:off x="4788960" y="1525099"/>
-            <a:ext cx="1055077" cy="737245"/>
-          </a:xfrm>
-          <a:prstGeom prst="straightConnector1">
-            <a:avLst/>
-          </a:prstGeom>
-          <a:ln>
-            <a:tailEnd type="triangle"/>
-          </a:ln>
-        </p:spPr>
-        <p:style>
-          <a:lnRef idx="2">
-            <a:schemeClr val="dk1"/>
-          </a:lnRef>
-          <a:fillRef idx="0">
-            <a:schemeClr val="dk1"/>
-          </a:fillRef>
-          <a:effectRef idx="1">
-            <a:schemeClr val="dk1"/>
-          </a:effectRef>
-          <a:fontRef idx="minor">
-            <a:schemeClr val="tx1"/>
-          </a:fontRef>
-        </p:style>
-      </p:cxnSp>
-      <p:sp>
-        <p:nvSpPr>
-          <p:cNvPr id="11" name="Rectangle 10">
-            <a:extLst>
-              <a:ext uri="{FF2B5EF4-FFF2-40B4-BE49-F238E27FC236}">
-                <a16:creationId xmlns:a16="http://schemas.microsoft.com/office/drawing/2014/main" id="{9E07A674-5075-208F-C87A-5CAFF44A6B1A}"/>
-              </a:ext>
-            </a:extLst>
-          </p:cNvPr>
-          <p:cNvSpPr/>
-          <p:nvPr/>
-        </p:nvSpPr>
-        <p:spPr>
-          <a:xfrm>
-            <a:off x="3892145" y="986750"/>
+            <a:off x="4947221" y="986750"/>
             <a:ext cx="1793630" cy="538349"/>
           </a:xfrm>
           <a:prstGeom prst="rect">
@@ -26341,6 +26623,47 @@
           </a:p>
         </p:txBody>
       </p:sp>
+      <p:cxnSp>
+        <p:nvCxnSpPr>
+          <p:cNvPr id="15" name="Straight Arrow Connector 14">
+            <a:extLst>
+              <a:ext uri="{FF2B5EF4-FFF2-40B4-BE49-F238E27FC236}">
+                <a16:creationId xmlns:a16="http://schemas.microsoft.com/office/drawing/2014/main" id="{7DFE2705-D969-2879-3374-2F2CC5030378}"/>
+              </a:ext>
+            </a:extLst>
+          </p:cNvPr>
+          <p:cNvCxnSpPr>
+            <a:stCxn id="14" idx="2"/>
+          </p:cNvCxnSpPr>
+          <p:nvPr/>
+        </p:nvCxnSpPr>
+        <p:spPr>
+          <a:xfrm>
+            <a:off x="5844036" y="1525099"/>
+            <a:ext cx="1" cy="737245"/>
+          </a:xfrm>
+          <a:prstGeom prst="straightConnector1">
+            <a:avLst/>
+          </a:prstGeom>
+          <a:ln>
+            <a:tailEnd type="triangle"/>
+          </a:ln>
+        </p:spPr>
+        <p:style>
+          <a:lnRef idx="3">
+            <a:schemeClr val="dk1"/>
+          </a:lnRef>
+          <a:fillRef idx="0">
+            <a:schemeClr val="dk1"/>
+          </a:fillRef>
+          <a:effectRef idx="2">
+            <a:schemeClr val="dk1"/>
+          </a:effectRef>
+          <a:fontRef idx="minor">
+            <a:schemeClr val="tx1"/>
+          </a:fontRef>
+        </p:style>
+      </p:cxnSp>
     </p:spTree>
     <p:extLst>
       <p:ext uri="{BB962C8B-B14F-4D97-AF65-F5344CB8AC3E}">
@@ -27288,7 +27611,7 @@
               <a:rPr lang="nl-NL" sz="1800" noProof="0" dirty="0">
                 <a:cs typeface="Courier New" panose="02070309020205020404" pitchFamily="49" charset="0"/>
               </a:rPr>
-              <a:t>; iedereen krijgt kopie van alles.</a:t>
+              <a:t>; versies zijn eenvoudig te delen.</a:t>
             </a:r>
           </a:p>
         </p:txBody>
@@ -27913,14 +28236,14 @@
           </a:ln>
         </p:spPr>
         <p:style>
-          <a:lnRef idx="2">
-            <a:schemeClr val="accent5"/>
+          <a:lnRef idx="3">
+            <a:schemeClr val="accent1"/>
           </a:lnRef>
           <a:fillRef idx="0">
-            <a:schemeClr val="accent5"/>
+            <a:schemeClr val="accent1"/>
           </a:fillRef>
-          <a:effectRef idx="1">
-            <a:schemeClr val="accent5"/>
+          <a:effectRef idx="2">
+            <a:schemeClr val="accent1"/>
           </a:effectRef>
           <a:fontRef idx="minor">
             <a:schemeClr val="tx1"/>
@@ -28103,6 +28426,42 @@
             <a:r>
               <a:rPr lang="nl-NL" noProof="0" dirty="0"/>
               <a:t>C</a:t>
+            </a:r>
+          </a:p>
+        </p:txBody>
+      </p:sp>
+      <p:sp>
+        <p:nvSpPr>
+          <p:cNvPr id="9" name="TextBox 8">
+            <a:extLst>
+              <a:ext uri="{FF2B5EF4-FFF2-40B4-BE49-F238E27FC236}">
+                <a16:creationId xmlns:a16="http://schemas.microsoft.com/office/drawing/2014/main" id="{CEF271A2-12E1-620A-B13E-51184B818E97}"/>
+              </a:ext>
+            </a:extLst>
+          </p:cNvPr>
+          <p:cNvSpPr txBox="1"/>
+          <p:nvPr/>
+        </p:nvSpPr>
+        <p:spPr>
+          <a:xfrm>
+            <a:off x="9619967" y="6471982"/>
+            <a:ext cx="2499246" cy="307777"/>
+          </a:xfrm>
+          <a:prstGeom prst="rect">
+            <a:avLst/>
+          </a:prstGeom>
+          <a:noFill/>
+        </p:spPr>
+        <p:txBody>
+          <a:bodyPr wrap="square">
+            <a:spAutoFit/>
+          </a:bodyPr>
+          <a:lstStyle/>
+          <a:p>
+            <a:pPr algn="r"/>
+            <a:r>
+              <a:rPr lang="en-US" sz="1400" dirty="0"/>
+              <a:t>D: new branch.</a:t>
             </a:r>
           </a:p>
         </p:txBody>
@@ -30911,7 +31270,7 @@
               <a:rPr lang="nl-NL" sz="1800" noProof="0" dirty="0">
                 <a:cs typeface="Courier New" panose="02070309020205020404" pitchFamily="49" charset="0"/>
               </a:rPr>
-              <a:t>Eenvoudig te werken aan verschillende versies.</a:t>
+              <a:t>Tegelijkertijd te werken aan verschillende versies.</a:t>
             </a:r>
           </a:p>
           <a:p>
@@ -31380,7 +31739,7 @@
         <p:cNvPr id="1" name="">
           <a:extLst>
             <a:ext uri="{FF2B5EF4-FFF2-40B4-BE49-F238E27FC236}">
-              <a16:creationId xmlns:a16="http://schemas.microsoft.com/office/drawing/2014/main" id="{A47F98E2-4369-58BF-5F17-AC958580E32D}"/>
+              <a16:creationId xmlns:a16="http://schemas.microsoft.com/office/drawing/2014/main" id="{C85F70A6-25D5-233C-A7DB-D49FCA8F3EDA}"/>
             </a:ext>
           </a:extLst>
         </p:cNvPr>
@@ -31397,104 +31756,10 @@
       </p:grpSpPr>
       <p:sp>
         <p:nvSpPr>
-          <p:cNvPr id="4" name="Title 3">
-            <a:extLst>
-              <a:ext uri="{FF2B5EF4-FFF2-40B4-BE49-F238E27FC236}">
-                <a16:creationId xmlns:a16="http://schemas.microsoft.com/office/drawing/2014/main" id="{528921DF-B3F4-5A97-74CC-BB389C751B9C}"/>
-              </a:ext>
-            </a:extLst>
-          </p:cNvPr>
-          <p:cNvSpPr>
-            <a:spLocks noGrp="1"/>
-          </p:cNvSpPr>
-          <p:nvPr>
-            <p:ph type="title"/>
-          </p:nvPr>
-        </p:nvSpPr>
-        <p:spPr/>
-        <p:txBody>
-          <a:bodyPr/>
-          <a:lstStyle/>
-          <a:p>
-            <a:r>
-              <a:rPr lang="nl-NL" noProof="0" dirty="0"/>
-              <a:t>Branches </a:t>
-            </a:r>
-            <a:r>
-              <a:rPr lang="nl-NL" noProof="0" dirty="0" err="1"/>
-              <a:t>mergen</a:t>
-            </a:r>
-            <a:endParaRPr lang="nl-NL" noProof="0" dirty="0"/>
-          </a:p>
-        </p:txBody>
-      </p:sp>
-      <p:sp>
-        <p:nvSpPr>
-          <p:cNvPr id="5" name="Text Placeholder 4">
-            <a:extLst>
-              <a:ext uri="{FF2B5EF4-FFF2-40B4-BE49-F238E27FC236}">
-                <a16:creationId xmlns:a16="http://schemas.microsoft.com/office/drawing/2014/main" id="{EEC93926-3830-5308-64DC-D6648F14B979}"/>
-              </a:ext>
-            </a:extLst>
-          </p:cNvPr>
-          <p:cNvSpPr>
-            <a:spLocks noGrp="1"/>
-          </p:cNvSpPr>
-          <p:nvPr>
-            <p:ph type="body" idx="1"/>
-          </p:nvPr>
-        </p:nvSpPr>
-        <p:spPr/>
-        <p:txBody>
-          <a:bodyPr/>
-          <a:lstStyle/>
-          <a:p>
-            <a:endParaRPr lang="nl-NL" noProof="0" dirty="0"/>
-          </a:p>
-        </p:txBody>
-      </p:sp>
-    </p:spTree>
-    <p:extLst>
-      <p:ext uri="{BB962C8B-B14F-4D97-AF65-F5344CB8AC3E}">
-        <p14:creationId xmlns:p14="http://schemas.microsoft.com/office/powerpoint/2010/main" val="2846076098"/>
-      </p:ext>
-    </p:extLst>
-  </p:cSld>
-  <p:clrMapOvr>
-    <a:masterClrMapping/>
-  </p:clrMapOvr>
-</p:sld>
-</file>
-
-<file path=ppt/slides/slide47.xml><?xml version="1.0" encoding="utf-8"?>
-<p:sld xmlns:a="http://schemas.openxmlformats.org/drawingml/2006/main" xmlns:r="http://schemas.openxmlformats.org/officeDocument/2006/relationships" xmlns:p="http://schemas.openxmlformats.org/presentationml/2006/main">
-  <p:cSld>
-    <p:spTree>
-      <p:nvGrpSpPr>
-        <p:cNvPr id="1" name="">
-          <a:extLst>
-            <a:ext uri="{FF2B5EF4-FFF2-40B4-BE49-F238E27FC236}">
-              <a16:creationId xmlns:a16="http://schemas.microsoft.com/office/drawing/2014/main" id="{AE28031C-3CBC-56DE-D8ED-443717FBA09C}"/>
-            </a:ext>
-          </a:extLst>
-        </p:cNvPr>
-        <p:cNvGrpSpPr/>
-        <p:nvPr/>
-      </p:nvGrpSpPr>
-      <p:grpSpPr>
-        <a:xfrm>
-          <a:off x="0" y="0"/>
-          <a:ext cx="0" cy="0"/>
-          <a:chOff x="0" y="0"/>
-          <a:chExt cx="0" cy="0"/>
-        </a:xfrm>
-      </p:grpSpPr>
-      <p:sp>
-        <p:nvSpPr>
           <p:cNvPr id="2" name="Title 1">
             <a:extLst>
               <a:ext uri="{FF2B5EF4-FFF2-40B4-BE49-F238E27FC236}">
-                <a16:creationId xmlns:a16="http://schemas.microsoft.com/office/drawing/2014/main" id="{C3DB6520-E17A-D8A3-817C-43EA4D52E3C3}"/>
+                <a16:creationId xmlns:a16="http://schemas.microsoft.com/office/drawing/2014/main" id="{EB131189-E6FD-AE06-7EC2-08AF3F28AF4B}"/>
               </a:ext>
             </a:extLst>
           </p:cNvPr>
@@ -31529,7 +31794,7 @@
           <p:cNvPr id="5" name="Straight Arrow Connector 4">
             <a:extLst>
               <a:ext uri="{FF2B5EF4-FFF2-40B4-BE49-F238E27FC236}">
-                <a16:creationId xmlns:a16="http://schemas.microsoft.com/office/drawing/2014/main" id="{76C89548-930D-873C-D391-EE4EE70955C4}"/>
+                <a16:creationId xmlns:a16="http://schemas.microsoft.com/office/drawing/2014/main" id="{2D6D920B-7391-89FC-92CD-3589FF4D01C7}"/>
               </a:ext>
             </a:extLst>
           </p:cNvPr>
@@ -31570,7 +31835,7 @@
           <p:cNvPr id="56" name="Oval 55">
             <a:extLst>
               <a:ext uri="{FF2B5EF4-FFF2-40B4-BE49-F238E27FC236}">
-                <a16:creationId xmlns:a16="http://schemas.microsoft.com/office/drawing/2014/main" id="{B978E60B-444F-B4C5-6A9B-AB8325B7A836}"/>
+                <a16:creationId xmlns:a16="http://schemas.microsoft.com/office/drawing/2014/main" id="{A9B70236-3AE5-722F-B8EC-278283BE5059}"/>
               </a:ext>
             </a:extLst>
           </p:cNvPr>
@@ -31623,7 +31888,7 @@
           <p:cNvPr id="57" name="Oval 56">
             <a:extLst>
               <a:ext uri="{FF2B5EF4-FFF2-40B4-BE49-F238E27FC236}">
-                <a16:creationId xmlns:a16="http://schemas.microsoft.com/office/drawing/2014/main" id="{BA80AFB8-70FD-8C89-6043-CCDB21AC8070}"/>
+                <a16:creationId xmlns:a16="http://schemas.microsoft.com/office/drawing/2014/main" id="{99F5EA53-6B37-E165-A622-28512360A920}"/>
               </a:ext>
             </a:extLst>
           </p:cNvPr>
@@ -31676,7 +31941,7 @@
           <p:cNvPr id="12" name="Connector: Elbow 11">
             <a:extLst>
               <a:ext uri="{FF2B5EF4-FFF2-40B4-BE49-F238E27FC236}">
-                <a16:creationId xmlns:a16="http://schemas.microsoft.com/office/drawing/2014/main" id="{028E4221-E636-FA61-9600-833E989E6AB9}"/>
+                <a16:creationId xmlns:a16="http://schemas.microsoft.com/office/drawing/2014/main" id="{0EF47D92-BB8A-0D02-D188-504EAA42C746}"/>
               </a:ext>
             </a:extLst>
           </p:cNvPr>
@@ -31718,7 +31983,7 @@
           <p:cNvPr id="9" name="TextBox 8">
             <a:extLst>
               <a:ext uri="{FF2B5EF4-FFF2-40B4-BE49-F238E27FC236}">
-                <a16:creationId xmlns:a16="http://schemas.microsoft.com/office/drawing/2014/main" id="{C00E020D-8DEC-19E9-7417-D5FE765970E2}"/>
+                <a16:creationId xmlns:a16="http://schemas.microsoft.com/office/drawing/2014/main" id="{0DE9E2C2-0DA5-F042-C63B-DA132EB373E0}"/>
               </a:ext>
             </a:extLst>
           </p:cNvPr>
@@ -31754,7 +32019,7 @@
           <p:cNvPr id="14" name="TextBox 13">
             <a:extLst>
               <a:ext uri="{FF2B5EF4-FFF2-40B4-BE49-F238E27FC236}">
-                <a16:creationId xmlns:a16="http://schemas.microsoft.com/office/drawing/2014/main" id="{A1D3F63B-FB97-8257-256B-83738B03C890}"/>
+                <a16:creationId xmlns:a16="http://schemas.microsoft.com/office/drawing/2014/main" id="{2FBB599E-9932-CED7-6D08-60D72B9C932D}"/>
               </a:ext>
             </a:extLst>
           </p:cNvPr>
@@ -31790,7 +32055,7 @@
           <p:cNvPr id="19" name="Oval 18">
             <a:extLst>
               <a:ext uri="{FF2B5EF4-FFF2-40B4-BE49-F238E27FC236}">
-                <a16:creationId xmlns:a16="http://schemas.microsoft.com/office/drawing/2014/main" id="{EBBC4958-918E-AC89-4AC3-E50D13D548FD}"/>
+                <a16:creationId xmlns:a16="http://schemas.microsoft.com/office/drawing/2014/main" id="{65D16238-2C0F-9FEF-CD8D-741B782D5500}"/>
               </a:ext>
             </a:extLst>
           </p:cNvPr>
@@ -31843,7 +32108,7 @@
           <p:cNvPr id="25" name="Connector: Elbow 24">
             <a:extLst>
               <a:ext uri="{FF2B5EF4-FFF2-40B4-BE49-F238E27FC236}">
-                <a16:creationId xmlns:a16="http://schemas.microsoft.com/office/drawing/2014/main" id="{B35F3121-77B4-8EDA-C162-D2B7E5B28138}"/>
+                <a16:creationId xmlns:a16="http://schemas.microsoft.com/office/drawing/2014/main" id="{605AF9AA-3707-0846-B8D0-D7A9099693DE}"/>
               </a:ext>
             </a:extLst>
           </p:cNvPr>
@@ -31885,7 +32150,7 @@
           <p:cNvPr id="23" name="Oval 22">
             <a:extLst>
               <a:ext uri="{FF2B5EF4-FFF2-40B4-BE49-F238E27FC236}">
-                <a16:creationId xmlns:a16="http://schemas.microsoft.com/office/drawing/2014/main" id="{022CC741-2E51-90CC-2DF3-3C1B42F468F6}"/>
+                <a16:creationId xmlns:a16="http://schemas.microsoft.com/office/drawing/2014/main" id="{E6E51369-E5E1-84B3-D3DA-9EBD6F933A6C}"/>
               </a:ext>
             </a:extLst>
           </p:cNvPr>
@@ -31938,7 +32203,7 @@
           <p:cNvPr id="27" name="TextBox 26">
             <a:extLst>
               <a:ext uri="{FF2B5EF4-FFF2-40B4-BE49-F238E27FC236}">
-                <a16:creationId xmlns:a16="http://schemas.microsoft.com/office/drawing/2014/main" id="{9C0530DB-06F3-DA27-170C-2452A4600EB2}"/>
+                <a16:creationId xmlns:a16="http://schemas.microsoft.com/office/drawing/2014/main" id="{6D139C2F-9AB4-913A-1AAD-FBD77A59C1B6}"/>
               </a:ext>
             </a:extLst>
           </p:cNvPr>
@@ -31973,7 +32238,7 @@
           <p:cNvPr id="3" name="Oval 2">
             <a:extLst>
               <a:ext uri="{FF2B5EF4-FFF2-40B4-BE49-F238E27FC236}">
-                <a16:creationId xmlns:a16="http://schemas.microsoft.com/office/drawing/2014/main" id="{56040F26-B2E2-B94E-9C3A-149F5CD097FC}"/>
+                <a16:creationId xmlns:a16="http://schemas.microsoft.com/office/drawing/2014/main" id="{C1A48631-A715-ED6E-9A7A-7F30C807542F}"/>
               </a:ext>
             </a:extLst>
           </p:cNvPr>
@@ -32026,7 +32291,7 @@
           <p:cNvPr id="4" name="Oval 3">
             <a:extLst>
               <a:ext uri="{FF2B5EF4-FFF2-40B4-BE49-F238E27FC236}">
-                <a16:creationId xmlns:a16="http://schemas.microsoft.com/office/drawing/2014/main" id="{0DA6955C-D85B-E06F-C611-46227E0919B3}"/>
+                <a16:creationId xmlns:a16="http://schemas.microsoft.com/office/drawing/2014/main" id="{2CED0B24-E9D7-DE83-C789-6F9CCE31D5FB}"/>
               </a:ext>
             </a:extLst>
           </p:cNvPr>
@@ -32074,10 +32339,231 @@
           </a:p>
         </p:txBody>
       </p:sp>
+      <p:sp>
+        <p:nvSpPr>
+          <p:cNvPr id="6" name="Rectangle 5">
+            <a:extLst>
+              <a:ext uri="{FF2B5EF4-FFF2-40B4-BE49-F238E27FC236}">
+                <a16:creationId xmlns:a16="http://schemas.microsoft.com/office/drawing/2014/main" id="{20D8F1E7-6EE6-5337-F7F1-0F3569CC21A8}"/>
+              </a:ext>
+            </a:extLst>
+          </p:cNvPr>
+          <p:cNvSpPr/>
+          <p:nvPr/>
+        </p:nvSpPr>
+        <p:spPr>
+          <a:xfrm>
+            <a:off x="493381" y="1756437"/>
+            <a:ext cx="11235937" cy="2065623"/>
+          </a:xfrm>
+          <a:prstGeom prst="rect">
+            <a:avLst/>
+          </a:prstGeom>
+          <a:noFill/>
+        </p:spPr>
+        <p:style>
+          <a:lnRef idx="2">
+            <a:schemeClr val="accent6"/>
+          </a:lnRef>
+          <a:fillRef idx="1">
+            <a:schemeClr val="lt1"/>
+          </a:fillRef>
+          <a:effectRef idx="0">
+            <a:schemeClr val="accent6"/>
+          </a:effectRef>
+          <a:fontRef idx="minor">
+            <a:schemeClr val="dk1"/>
+          </a:fontRef>
+        </p:style>
+        <p:txBody>
+          <a:bodyPr rtlCol="0" anchor="t"/>
+          <a:lstStyle/>
+          <a:p>
+            <a:r>
+              <a:rPr lang="en-US" dirty="0" err="1">
+                <a:solidFill>
+                  <a:schemeClr val="accent6">
+                    <a:lumMod val="75000"/>
+                  </a:schemeClr>
+                </a:solidFill>
+              </a:rPr>
+              <a:t>gedeeld</a:t>
+            </a:r>
+            <a:endParaRPr lang="en-US" dirty="0">
+              <a:solidFill>
+                <a:schemeClr val="accent6">
+                  <a:lumMod val="75000"/>
+                </a:schemeClr>
+              </a:solidFill>
+            </a:endParaRPr>
+          </a:p>
+        </p:txBody>
+      </p:sp>
+      <p:sp>
+        <p:nvSpPr>
+          <p:cNvPr id="7" name="Rectangle 6">
+            <a:extLst>
+              <a:ext uri="{FF2B5EF4-FFF2-40B4-BE49-F238E27FC236}">
+                <a16:creationId xmlns:a16="http://schemas.microsoft.com/office/drawing/2014/main" id="{95600708-4B1C-52A1-27D5-30DBF4CF75D0}"/>
+              </a:ext>
+            </a:extLst>
+          </p:cNvPr>
+          <p:cNvSpPr/>
+          <p:nvPr/>
+        </p:nvSpPr>
+        <p:spPr>
+          <a:xfrm>
+            <a:off x="493380" y="3822060"/>
+            <a:ext cx="11235937" cy="942495"/>
+          </a:xfrm>
+          <a:prstGeom prst="rect">
+            <a:avLst/>
+          </a:prstGeom>
+          <a:noFill/>
+          <a:ln>
+            <a:solidFill>
+              <a:schemeClr val="accent2">
+                <a:lumMod val="75000"/>
+              </a:schemeClr>
+            </a:solidFill>
+          </a:ln>
+        </p:spPr>
+        <p:style>
+          <a:lnRef idx="2">
+            <a:schemeClr val="accent6"/>
+          </a:lnRef>
+          <a:fillRef idx="1">
+            <a:schemeClr val="lt1"/>
+          </a:fillRef>
+          <a:effectRef idx="0">
+            <a:schemeClr val="accent6"/>
+          </a:effectRef>
+          <a:fontRef idx="minor">
+            <a:schemeClr val="dk1"/>
+          </a:fontRef>
+        </p:style>
+        <p:txBody>
+          <a:bodyPr rtlCol="0" anchor="t"/>
+          <a:lstStyle/>
+          <a:p>
+            <a:r>
+              <a:rPr lang="en-US" dirty="0" err="1">
+                <a:solidFill>
+                  <a:schemeClr val="accent2">
+                    <a:lumMod val="75000"/>
+                  </a:schemeClr>
+                </a:solidFill>
+              </a:rPr>
+              <a:t>persoonlijk</a:t>
+            </a:r>
+            <a:endParaRPr lang="en-US" dirty="0">
+              <a:solidFill>
+                <a:schemeClr val="accent2">
+                  <a:lumMod val="75000"/>
+                </a:schemeClr>
+              </a:solidFill>
+            </a:endParaRPr>
+          </a:p>
+        </p:txBody>
+      </p:sp>
     </p:spTree>
     <p:extLst>
       <p:ext uri="{BB962C8B-B14F-4D97-AF65-F5344CB8AC3E}">
-        <p14:creationId xmlns:p14="http://schemas.microsoft.com/office/powerpoint/2010/main" val="376317442"/>
+        <p14:creationId xmlns:p14="http://schemas.microsoft.com/office/powerpoint/2010/main" val="2907842847"/>
+      </p:ext>
+    </p:extLst>
+  </p:cSld>
+  <p:clrMapOvr>
+    <a:masterClrMapping/>
+  </p:clrMapOvr>
+</p:sld>
+</file>
+
+<file path=ppt/slides/slide47.xml><?xml version="1.0" encoding="utf-8"?>
+<p:sld xmlns:a="http://schemas.openxmlformats.org/drawingml/2006/main" xmlns:r="http://schemas.openxmlformats.org/officeDocument/2006/relationships" xmlns:p="http://schemas.openxmlformats.org/presentationml/2006/main">
+  <p:cSld>
+    <p:spTree>
+      <p:nvGrpSpPr>
+        <p:cNvPr id="1" name="">
+          <a:extLst>
+            <a:ext uri="{FF2B5EF4-FFF2-40B4-BE49-F238E27FC236}">
+              <a16:creationId xmlns:a16="http://schemas.microsoft.com/office/drawing/2014/main" id="{A47F98E2-4369-58BF-5F17-AC958580E32D}"/>
+            </a:ext>
+          </a:extLst>
+        </p:cNvPr>
+        <p:cNvGrpSpPr/>
+        <p:nvPr/>
+      </p:nvGrpSpPr>
+      <p:grpSpPr>
+        <a:xfrm>
+          <a:off x="0" y="0"/>
+          <a:ext cx="0" cy="0"/>
+          <a:chOff x="0" y="0"/>
+          <a:chExt cx="0" cy="0"/>
+        </a:xfrm>
+      </p:grpSpPr>
+      <p:sp>
+        <p:nvSpPr>
+          <p:cNvPr id="4" name="Title 3">
+            <a:extLst>
+              <a:ext uri="{FF2B5EF4-FFF2-40B4-BE49-F238E27FC236}">
+                <a16:creationId xmlns:a16="http://schemas.microsoft.com/office/drawing/2014/main" id="{528921DF-B3F4-5A97-74CC-BB389C751B9C}"/>
+              </a:ext>
+            </a:extLst>
+          </p:cNvPr>
+          <p:cNvSpPr>
+            <a:spLocks noGrp="1"/>
+          </p:cNvSpPr>
+          <p:nvPr>
+            <p:ph type="title"/>
+          </p:nvPr>
+        </p:nvSpPr>
+        <p:spPr/>
+        <p:txBody>
+          <a:bodyPr/>
+          <a:lstStyle/>
+          <a:p>
+            <a:r>
+              <a:rPr lang="nl-NL" noProof="0" dirty="0"/>
+              <a:t>Branches </a:t>
+            </a:r>
+            <a:r>
+              <a:rPr lang="nl-NL" noProof="0" dirty="0" err="1"/>
+              <a:t>mergen</a:t>
+            </a:r>
+            <a:endParaRPr lang="nl-NL" noProof="0" dirty="0"/>
+          </a:p>
+        </p:txBody>
+      </p:sp>
+      <p:sp>
+        <p:nvSpPr>
+          <p:cNvPr id="5" name="Text Placeholder 4">
+            <a:extLst>
+              <a:ext uri="{FF2B5EF4-FFF2-40B4-BE49-F238E27FC236}">
+                <a16:creationId xmlns:a16="http://schemas.microsoft.com/office/drawing/2014/main" id="{EEC93926-3830-5308-64DC-D6648F14B979}"/>
+              </a:ext>
+            </a:extLst>
+          </p:cNvPr>
+          <p:cNvSpPr>
+            <a:spLocks noGrp="1"/>
+          </p:cNvSpPr>
+          <p:nvPr>
+            <p:ph type="body" idx="1"/>
+          </p:nvPr>
+        </p:nvSpPr>
+        <p:spPr/>
+        <p:txBody>
+          <a:bodyPr/>
+          <a:lstStyle/>
+          <a:p>
+            <a:endParaRPr lang="nl-NL" noProof="0" dirty="0"/>
+          </a:p>
+        </p:txBody>
+      </p:sp>
+    </p:spTree>
+    <p:extLst>
+      <p:ext uri="{BB962C8B-B14F-4D97-AF65-F5344CB8AC3E}">
+        <p14:creationId xmlns:p14="http://schemas.microsoft.com/office/powerpoint/2010/main" val="2846076098"/>
       </p:ext>
     </p:extLst>
   </p:cSld>
@@ -33974,15 +34460,22 @@
             </a:endParaRPr>
           </a:p>
           <a:p>
-            <a:pPr>
-              <a:buFontTx/>
-              <a:buChar char="-"/>
+            <a:pPr marL="0" indent="0">
+              <a:buNone/>
             </a:pPr>
-            <a:r>
-              <a:rPr lang="nl-NL" sz="1800" dirty="0">
-                <a:cs typeface="Courier New" panose="02070309020205020404" pitchFamily="49" charset="0"/>
-              </a:rPr>
-              <a:t>Let op: eens in git, is altijd in git!</a:t>
+            <a:endParaRPr lang="nl-NL" sz="1800" dirty="0">
+              <a:cs typeface="Courier New" panose="02070309020205020404" pitchFamily="49" charset="0"/>
+            </a:endParaRPr>
+          </a:p>
+          <a:p>
+            <a:pPr marL="0" indent="0" algn="ctr">
+              <a:buNone/>
+            </a:pPr>
+            <a:r>
+              <a:rPr lang="nl-NL" sz="1800" b="1" dirty="0">
+                <a:cs typeface="Courier New" panose="02070309020205020404" pitchFamily="49" charset="0"/>
+              </a:rPr>
+              <a:t>Let op: Eens in git, is altijd in git!</a:t>
             </a:r>
           </a:p>
           <a:p>
@@ -35255,6 +35748,42 @@
           </a:fontRef>
         </p:style>
       </p:cxnSp>
+      <p:sp>
+        <p:nvSpPr>
+          <p:cNvPr id="17" name="TextBox 16">
+            <a:extLst>
+              <a:ext uri="{FF2B5EF4-FFF2-40B4-BE49-F238E27FC236}">
+                <a16:creationId xmlns:a16="http://schemas.microsoft.com/office/drawing/2014/main" id="{CADAA72C-DF6A-C16D-1882-D783CF6ED874}"/>
+              </a:ext>
+            </a:extLst>
+          </p:cNvPr>
+          <p:cNvSpPr txBox="1"/>
+          <p:nvPr/>
+        </p:nvSpPr>
+        <p:spPr>
+          <a:xfrm>
+            <a:off x="9619967" y="6471982"/>
+            <a:ext cx="2499246" cy="307777"/>
+          </a:xfrm>
+          <a:prstGeom prst="rect">
+            <a:avLst/>
+          </a:prstGeom>
+          <a:noFill/>
+        </p:spPr>
+        <p:txBody>
+          <a:bodyPr wrap="square">
+            <a:spAutoFit/>
+          </a:bodyPr>
+          <a:lstStyle/>
+          <a:p>
+            <a:pPr algn="r"/>
+            <a:r>
+              <a:rPr lang="en-US" sz="1400" dirty="0"/>
+              <a:t>D: merge ff</a:t>
+            </a:r>
+          </a:p>
+        </p:txBody>
+      </p:sp>
     </p:spTree>
     <p:extLst>
       <p:ext uri="{BB962C8B-B14F-4D97-AF65-F5344CB8AC3E}">
@@ -37344,6 +37873,42 @@
           </a:fontRef>
         </p:style>
       </p:cxnSp>
+      <p:sp>
+        <p:nvSpPr>
+          <p:cNvPr id="5" name="TextBox 4">
+            <a:extLst>
+              <a:ext uri="{FF2B5EF4-FFF2-40B4-BE49-F238E27FC236}">
+                <a16:creationId xmlns:a16="http://schemas.microsoft.com/office/drawing/2014/main" id="{CAAE406D-8C36-C04B-BAEB-F119DE440788}"/>
+              </a:ext>
+            </a:extLst>
+          </p:cNvPr>
+          <p:cNvSpPr txBox="1"/>
+          <p:nvPr/>
+        </p:nvSpPr>
+        <p:spPr>
+          <a:xfrm>
+            <a:off x="9619967" y="6471982"/>
+            <a:ext cx="2499246" cy="307777"/>
+          </a:xfrm>
+          <a:prstGeom prst="rect">
+            <a:avLst/>
+          </a:prstGeom>
+          <a:noFill/>
+        </p:spPr>
+        <p:txBody>
+          <a:bodyPr wrap="square">
+            <a:spAutoFit/>
+          </a:bodyPr>
+          <a:lstStyle/>
+          <a:p>
+            <a:pPr algn="r"/>
+            <a:r>
+              <a:rPr lang="en-US" sz="1400" dirty="0"/>
+              <a:t>D: merge no ff</a:t>
+            </a:r>
+          </a:p>
+        </p:txBody>
+      </p:sp>
     </p:spTree>
     <p:extLst>
       <p:ext uri="{BB962C8B-B14F-4D97-AF65-F5344CB8AC3E}">
@@ -39098,23 +39663,11 @@
             <a:pPr algn="ctr"/>
             <a:r>
               <a:rPr lang="nl-NL" dirty="0"/>
-              <a:t>Maak </a:t>
+              <a:t>Maak commit B </a:t>
             </a:r>
             <a:r>
               <a:rPr lang="nl-NL" dirty="0" err="1"/>
               <a:t>parent</a:t>
-            </a:r>
-            <a:r>
-              <a:rPr lang="nl-NL" dirty="0"/>
-              <a:t> </a:t>
-            </a:r>
-            <a:r>
-              <a:rPr lang="nl-NL" dirty="0" err="1"/>
-              <a:t>commit</a:t>
-            </a:r>
-            <a:r>
-              <a:rPr lang="nl-NL" dirty="0"/>
-              <a:t> B</a:t>
             </a:r>
             <a:endParaRPr lang="nl-NL" noProof="0" dirty="0"/>
           </a:p>
@@ -40395,13 +40948,20 @@
           <a:p>
             <a:pPr algn="ctr"/>
             <a:r>
+              <a:rPr lang="nl-NL" noProof="0" dirty="0"/>
+              <a:t>Na </a:t>
+            </a:r>
+            <a:r>
               <a:rPr lang="nl-NL" noProof="0" dirty="0" err="1"/>
-              <a:t>Permorm</a:t>
+              <a:t>rebase</a:t>
             </a:r>
             <a:r>
               <a:rPr lang="nl-NL" noProof="0" dirty="0"/>
-              <a:t> </a:t>
-            </a:r>
+              <a:t> volgt</a:t>
+            </a:r>
+          </a:p>
+          <a:p>
+            <a:pPr algn="ctr"/>
             <a:r>
               <a:rPr lang="nl-NL" noProof="0" dirty="0" err="1"/>
               <a:t>fast</a:t>
@@ -40580,6 +41140,42 @@
               <a:latin typeface="Courier New" panose="02070309020205020404" pitchFamily="49" charset="0"/>
               <a:cs typeface="Courier New" panose="02070309020205020404" pitchFamily="49" charset="0"/>
             </a:endParaRPr>
+          </a:p>
+        </p:txBody>
+      </p:sp>
+      <p:sp>
+        <p:nvSpPr>
+          <p:cNvPr id="21" name="TextBox 20">
+            <a:extLst>
+              <a:ext uri="{FF2B5EF4-FFF2-40B4-BE49-F238E27FC236}">
+                <a16:creationId xmlns:a16="http://schemas.microsoft.com/office/drawing/2014/main" id="{6E6F66BE-8142-2674-5CDA-781A0E76FD52}"/>
+              </a:ext>
+            </a:extLst>
+          </p:cNvPr>
+          <p:cNvSpPr txBox="1"/>
+          <p:nvPr/>
+        </p:nvSpPr>
+        <p:spPr>
+          <a:xfrm>
+            <a:off x="9619967" y="6471982"/>
+            <a:ext cx="2499246" cy="307777"/>
+          </a:xfrm>
+          <a:prstGeom prst="rect">
+            <a:avLst/>
+          </a:prstGeom>
+          <a:noFill/>
+        </p:spPr>
+        <p:txBody>
+          <a:bodyPr wrap="square">
+            <a:spAutoFit/>
+          </a:bodyPr>
+          <a:lstStyle/>
+          <a:p>
+            <a:pPr algn="r"/>
+            <a:r>
+              <a:rPr lang="en-US" sz="1400" dirty="0"/>
+              <a:t>D: merge rebase</a:t>
+            </a:r>
           </a:p>
         </p:txBody>
       </p:sp>
@@ -43868,6 +44464,42 @@
               <a:t>ahead</a:t>
             </a:r>
             <a:endParaRPr lang="nl-NL" noProof="0" dirty="0"/>
+          </a:p>
+        </p:txBody>
+      </p:sp>
+      <p:sp>
+        <p:nvSpPr>
+          <p:cNvPr id="21" name="TextBox 20">
+            <a:extLst>
+              <a:ext uri="{FF2B5EF4-FFF2-40B4-BE49-F238E27FC236}">
+                <a16:creationId xmlns:a16="http://schemas.microsoft.com/office/drawing/2014/main" id="{121D78A0-9880-7290-5BC6-1390C115A529}"/>
+              </a:ext>
+            </a:extLst>
+          </p:cNvPr>
+          <p:cNvSpPr txBox="1"/>
+          <p:nvPr/>
+        </p:nvSpPr>
+        <p:spPr>
+          <a:xfrm>
+            <a:off x="9619967" y="6471982"/>
+            <a:ext cx="2499246" cy="307777"/>
+          </a:xfrm>
+          <a:prstGeom prst="rect">
+            <a:avLst/>
+          </a:prstGeom>
+          <a:noFill/>
+        </p:spPr>
+        <p:txBody>
+          <a:bodyPr wrap="square">
+            <a:spAutoFit/>
+          </a:bodyPr>
+          <a:lstStyle/>
+          <a:p>
+            <a:pPr algn="r"/>
+            <a:r>
+              <a:rPr lang="en-US" sz="1400" dirty="0"/>
+              <a:t>D: merge squash</a:t>
+            </a:r>
           </a:p>
         </p:txBody>
       </p:sp>
@@ -48681,7 +49313,7 @@
               <a:rPr lang="nl-NL" sz="1800" noProof="0" dirty="0">
                 <a:cs typeface="Courier New" panose="02070309020205020404" pitchFamily="49" charset="0"/>
               </a:rPr>
-              <a:t>Om het bestand te herstellen, gebruik:</a:t>
+              <a:t>Om het bestand te herstellen:</a:t>
             </a:r>
           </a:p>
           <a:p>
@@ -48749,19 +49381,7 @@
               <a:rPr lang="nl-NL" sz="1800" b="1" noProof="0" dirty="0">
                 <a:cs typeface="Courier New" panose="02070309020205020404" pitchFamily="49" charset="0"/>
               </a:rPr>
-              <a:t>Tot slot</a:t>
-            </a:r>
-            <a:r>
-              <a:rPr lang="nl-NL" sz="1800" b="1" noProof="0">
-                <a:cs typeface="Courier New" panose="02070309020205020404" pitchFamily="49" charset="0"/>
-              </a:rPr>
-              <a:t>: commit </a:t>
-            </a:r>
-            <a:r>
-              <a:rPr lang="nl-NL" sz="1800" b="1" noProof="0" dirty="0">
-                <a:cs typeface="Courier New" panose="02070309020205020404" pitchFamily="49" charset="0"/>
-              </a:rPr>
-              <a:t>de wijzigingen!</a:t>
+              <a:t>Tot slot: commit de wijzigingen!</a:t>
             </a:r>
           </a:p>
           <a:p>
@@ -48936,6 +49556,42 @@
               <a:latin typeface="Courier New" panose="02070309020205020404" pitchFamily="49" charset="0"/>
               <a:cs typeface="Courier New" panose="02070309020205020404" pitchFamily="49" charset="0"/>
             </a:endParaRPr>
+          </a:p>
+        </p:txBody>
+      </p:sp>
+      <p:sp>
+        <p:nvSpPr>
+          <p:cNvPr id="3" name="TextBox 2">
+            <a:extLst>
+              <a:ext uri="{FF2B5EF4-FFF2-40B4-BE49-F238E27FC236}">
+                <a16:creationId xmlns:a16="http://schemas.microsoft.com/office/drawing/2014/main" id="{B691CA9A-A513-934A-E497-C7F119C98419}"/>
+              </a:ext>
+            </a:extLst>
+          </p:cNvPr>
+          <p:cNvSpPr txBox="1"/>
+          <p:nvPr/>
+        </p:nvSpPr>
+        <p:spPr>
+          <a:xfrm>
+            <a:off x="9619967" y="6471982"/>
+            <a:ext cx="2499246" cy="307777"/>
+          </a:xfrm>
+          <a:prstGeom prst="rect">
+            <a:avLst/>
+          </a:prstGeom>
+          <a:noFill/>
+        </p:spPr>
+        <p:txBody>
+          <a:bodyPr wrap="square">
+            <a:spAutoFit/>
+          </a:bodyPr>
+          <a:lstStyle/>
+          <a:p>
+            <a:pPr algn="r"/>
+            <a:r>
+              <a:rPr lang="en-US" sz="1400" dirty="0"/>
+              <a:t>D: merge conflict</a:t>
+            </a:r>
           </a:p>
         </p:txBody>
       </p:sp>
@@ -50372,14 +51028,14 @@
           </a:ln>
         </p:spPr>
         <p:style>
-          <a:lnRef idx="2">
-            <a:schemeClr val="dk1"/>
+          <a:lnRef idx="3">
+            <a:schemeClr val="accent6"/>
           </a:lnRef>
           <a:fillRef idx="0">
-            <a:schemeClr val="dk1"/>
+            <a:schemeClr val="accent6"/>
           </a:fillRef>
-          <a:effectRef idx="1">
-            <a:schemeClr val="dk1"/>
+          <a:effectRef idx="2">
+            <a:schemeClr val="accent6"/>
           </a:effectRef>
           <a:fontRef idx="minor">
             <a:schemeClr val="tx1"/>
@@ -50415,18 +51071,42 @@
           <a:lstStyle/>
           <a:p>
             <a:r>
-              <a:rPr lang="nl-NL" dirty="0" err="1"/>
+              <a:rPr lang="nl-NL" dirty="0" err="1">
+                <a:solidFill>
+                  <a:schemeClr val="accent6">
+                    <a:lumMod val="75000"/>
+                  </a:schemeClr>
+                </a:solidFill>
+              </a:rPr>
               <a:t>merge</a:t>
             </a:r>
             <a:r>
-              <a:rPr lang="nl-NL" dirty="0"/>
+              <a:rPr lang="nl-NL" dirty="0">
+                <a:solidFill>
+                  <a:schemeClr val="accent6">
+                    <a:lumMod val="75000"/>
+                  </a:schemeClr>
+                </a:solidFill>
+              </a:rPr>
               <a:t> </a:t>
             </a:r>
             <a:r>
-              <a:rPr lang="nl-NL" dirty="0" err="1"/>
+              <a:rPr lang="nl-NL" dirty="0" err="1">
+                <a:solidFill>
+                  <a:schemeClr val="accent6">
+                    <a:lumMod val="75000"/>
+                  </a:schemeClr>
+                </a:solidFill>
+              </a:rPr>
               <a:t>develop</a:t>
             </a:r>
-            <a:endParaRPr lang="nl-NL" dirty="0"/>
+            <a:endParaRPr lang="nl-NL" dirty="0">
+              <a:solidFill>
+                <a:schemeClr val="accent6">
+                  <a:lumMod val="75000"/>
+                </a:schemeClr>
+              </a:solidFill>
+            </a:endParaRPr>
           </a:p>
         </p:txBody>
       </p:sp>
@@ -51477,7 +52157,7 @@
             </a:pPr>
             <a:r>
               <a:rPr lang="nl-NL" dirty="0"/>
-              <a:t>Toegevoegd aan staging area.</a:t>
+              <a:t>Toegevoegd aan staging area / index.</a:t>
             </a:r>
           </a:p>
         </p:txBody>
@@ -51865,7 +52545,7 @@
               <a:pPr algn="ctr"/>
               <a:r>
                 <a:rPr lang="en-US" b="1" dirty="0"/>
-                <a:t>staging area</a:t>
+                <a:t>staging area / index</a:t>
               </a:r>
             </a:p>
             <a:p>
@@ -52709,7 +53389,7 @@
               <a:pPr algn="ctr"/>
               <a:r>
                 <a:rPr lang="en-US" b="1" dirty="0"/>
-                <a:t>staging area</a:t>
+                <a:t>staging area / index</a:t>
               </a:r>
             </a:p>
             <a:p>

</xml_diff>